<commit_message>
Fix document download and preview buttons in reviewer and candidate workflows
</commit_message>
<xml_diff>
--- a/output/pptx/HM26-C3B5_presentation.pptx
+++ b/output/pptx/HM26-C3B5_presentation.pptx
@@ -5,18 +5,19 @@
     <p:sldMasterId id="2147483648" r:id="rId1"/>
   </p:sldMasterIdLst>
   <p:sldIdLst>
-    <p:sldId id="256" r:id="rId7"/>
-    <p:sldId id="257" r:id="rId8"/>
-    <p:sldId id="258" r:id="rId9"/>
-    <p:sldId id="259" r:id="rId10"/>
-    <p:sldId id="260" r:id="rId11"/>
-    <p:sldId id="261" r:id="rId12"/>
-    <p:sldId id="262" r:id="rId13"/>
-    <p:sldId id="263" r:id="rId14"/>
-    <p:sldId id="264" r:id="rId15"/>
-    <p:sldId id="265" r:id="rId16"/>
+    <p:sldId id="256" r:id="rId2"/>
+    <p:sldId id="257" r:id="rId3"/>
+    <p:sldId id="258" r:id="rId4"/>
+    <p:sldId id="259" r:id="rId5"/>
+    <p:sldId id="260" r:id="rId6"/>
+    <p:sldId id="261" r:id="rId7"/>
+    <p:sldId id="262" r:id="rId8"/>
+    <p:sldId id="263" r:id="rId9"/>
+    <p:sldId id="264" r:id="rId10"/>
+    <p:sldId id="266" r:id="rId11"/>
+    <p:sldId id="265" r:id="rId12"/>
   </p:sldIdLst>
-  <p:sldSz cx="12191695" cy="6858000" type="screen4x3"/>
+  <p:sldSz cx="12192000" cy="6858000"/>
   <p:notesSz cx="6858000" cy="9144000"/>
   <p:defaultTextStyle>
     <a:defPPr>
@@ -113,6 +114,22 @@
       </a:defRPr>
     </a:lvl9pPr>
   </p:defaultTextStyle>
+  <p:extLst>
+    <p:ext uri="{EFAFB233-063F-42B5-8137-9DF3F51BA10A}">
+      <p15:sldGuideLst xmlns:p15="http://schemas.microsoft.com/office/powerpoint/2012/main">
+        <p15:guide id="1" orient="horz" pos="2160">
+          <p15:clr>
+            <a:srgbClr val="A4A3A4"/>
+          </p15:clr>
+        </p15:guide>
+        <p15:guide id="2" pos="2880">
+          <p15:clr>
+            <a:srgbClr val="A4A3A4"/>
+          </p15:clr>
+        </p15:guide>
+      </p15:sldGuideLst>
+    </p:ext>
+  </p:extLst>
 </p:presentation>
 </file>
 
@@ -154,10 +171,9 @@
           <a:lstStyle/>
           <a:p>
             <a:r>
-              <a:rPr lang="en-US" smtClean="0"/>
+              <a:rPr lang="en-US"/>
               <a:t>Click to edit Master title style</a:t>
             </a:r>
-            <a:endParaRPr lang="en-US"/>
           </a:p>
         </p:txBody>
       </p:sp>
@@ -273,10 +289,9 @@
           </a:lstStyle>
           <a:p>
             <a:r>
-              <a:rPr lang="en-US" smtClean="0"/>
+              <a:rPr lang="en-US"/>
               <a:t>Click to edit Master subtitle style</a:t>
             </a:r>
-            <a:endParaRPr lang="en-US"/>
           </a:p>
         </p:txBody>
       </p:sp>
@@ -297,7 +312,7 @@
           <a:p>
             <a:fld id="{5BCAD085-E8A6-8845-BD4E-CB4CCA059FC4}" type="datetimeFigureOut">
               <a:rPr lang="en-US" smtClean="0"/>
-              <a:t>1/27/13</a:t>
+              <a:t>9/27/2026</a:t>
             </a:fld>
             <a:endParaRPr lang="en-US"/>
           </a:p>
@@ -391,10 +406,9 @@
           <a:lstStyle/>
           <a:p>
             <a:r>
-              <a:rPr lang="en-US" smtClean="0"/>
+              <a:rPr lang="en-US"/>
               <a:t>Click to edit Master title style</a:t>
             </a:r>
-            <a:endParaRPr lang="en-US"/>
           </a:p>
         </p:txBody>
       </p:sp>
@@ -415,38 +429,37 @@
           <a:p>
             <a:pPr lvl="0"/>
             <a:r>
-              <a:rPr lang="en-US" smtClean="0"/>
+              <a:rPr lang="en-US"/>
               <a:t>Click to edit Master text styles</a:t>
             </a:r>
           </a:p>
           <a:p>
             <a:pPr lvl="1"/>
             <a:r>
-              <a:rPr lang="en-US" smtClean="0"/>
+              <a:rPr lang="en-US"/>
               <a:t>Second level</a:t>
             </a:r>
           </a:p>
           <a:p>
             <a:pPr lvl="2"/>
             <a:r>
-              <a:rPr lang="en-US" smtClean="0"/>
+              <a:rPr lang="en-US"/>
               <a:t>Third level</a:t>
             </a:r>
           </a:p>
           <a:p>
             <a:pPr lvl="3"/>
             <a:r>
-              <a:rPr lang="en-US" smtClean="0"/>
+              <a:rPr lang="en-US"/>
               <a:t>Fourth level</a:t>
             </a:r>
           </a:p>
           <a:p>
             <a:pPr lvl="4"/>
             <a:r>
-              <a:rPr lang="en-US" smtClean="0"/>
+              <a:rPr lang="en-US"/>
               <a:t>Fifth level</a:t>
             </a:r>
-            <a:endParaRPr lang="en-US"/>
           </a:p>
         </p:txBody>
       </p:sp>
@@ -467,7 +480,7 @@
           <a:p>
             <a:fld id="{5BCAD085-E8A6-8845-BD4E-CB4CCA059FC4}" type="datetimeFigureOut">
               <a:rPr lang="en-US" smtClean="0"/>
-              <a:t>1/27/13</a:t>
+              <a:t>9/27/2026</a:t>
             </a:fld>
             <a:endParaRPr lang="en-US"/>
           </a:p>
@@ -566,10 +579,9 @@
           <a:lstStyle/>
           <a:p>
             <a:r>
-              <a:rPr lang="en-US" smtClean="0"/>
+              <a:rPr lang="en-US"/>
               <a:t>Click to edit Master title style</a:t>
             </a:r>
-            <a:endParaRPr lang="en-US"/>
           </a:p>
         </p:txBody>
       </p:sp>
@@ -595,38 +607,37 @@
           <a:p>
             <a:pPr lvl="0"/>
             <a:r>
-              <a:rPr lang="en-US" smtClean="0"/>
+              <a:rPr lang="en-US"/>
               <a:t>Click to edit Master text styles</a:t>
             </a:r>
           </a:p>
           <a:p>
             <a:pPr lvl="1"/>
             <a:r>
-              <a:rPr lang="en-US" smtClean="0"/>
+              <a:rPr lang="en-US"/>
               <a:t>Second level</a:t>
             </a:r>
           </a:p>
           <a:p>
             <a:pPr lvl="2"/>
             <a:r>
-              <a:rPr lang="en-US" smtClean="0"/>
+              <a:rPr lang="en-US"/>
               <a:t>Third level</a:t>
             </a:r>
           </a:p>
           <a:p>
             <a:pPr lvl="3"/>
             <a:r>
-              <a:rPr lang="en-US" smtClean="0"/>
+              <a:rPr lang="en-US"/>
               <a:t>Fourth level</a:t>
             </a:r>
           </a:p>
           <a:p>
             <a:pPr lvl="4"/>
             <a:r>
-              <a:rPr lang="en-US" smtClean="0"/>
+              <a:rPr lang="en-US"/>
               <a:t>Fifth level</a:t>
             </a:r>
-            <a:endParaRPr lang="en-US"/>
           </a:p>
         </p:txBody>
       </p:sp>
@@ -647,7 +658,7 @@
           <a:p>
             <a:fld id="{5BCAD085-E8A6-8845-BD4E-CB4CCA059FC4}" type="datetimeFigureOut">
               <a:rPr lang="en-US" smtClean="0"/>
-              <a:t>1/27/13</a:t>
+              <a:t>9/27/2026</a:t>
             </a:fld>
             <a:endParaRPr lang="en-US"/>
           </a:p>
@@ -741,10 +752,9 @@
           <a:lstStyle/>
           <a:p>
             <a:r>
-              <a:rPr lang="en-US" smtClean="0"/>
+              <a:rPr lang="en-US"/>
               <a:t>Click to edit Master title style</a:t>
             </a:r>
-            <a:endParaRPr lang="en-US"/>
           </a:p>
         </p:txBody>
       </p:sp>
@@ -765,38 +775,37 @@
           <a:p>
             <a:pPr lvl="0"/>
             <a:r>
-              <a:rPr lang="en-US" smtClean="0"/>
+              <a:rPr lang="en-US"/>
               <a:t>Click to edit Master text styles</a:t>
             </a:r>
           </a:p>
           <a:p>
             <a:pPr lvl="1"/>
             <a:r>
-              <a:rPr lang="en-US" smtClean="0"/>
+              <a:rPr lang="en-US"/>
               <a:t>Second level</a:t>
             </a:r>
           </a:p>
           <a:p>
             <a:pPr lvl="2"/>
             <a:r>
-              <a:rPr lang="en-US" smtClean="0"/>
+              <a:rPr lang="en-US"/>
               <a:t>Third level</a:t>
             </a:r>
           </a:p>
           <a:p>
             <a:pPr lvl="3"/>
             <a:r>
-              <a:rPr lang="en-US" smtClean="0"/>
+              <a:rPr lang="en-US"/>
               <a:t>Fourth level</a:t>
             </a:r>
           </a:p>
           <a:p>
             <a:pPr lvl="4"/>
             <a:r>
-              <a:rPr lang="en-US" smtClean="0"/>
+              <a:rPr lang="en-US"/>
               <a:t>Fifth level</a:t>
             </a:r>
-            <a:endParaRPr lang="en-US"/>
           </a:p>
         </p:txBody>
       </p:sp>
@@ -817,7 +826,7 @@
           <a:p>
             <a:fld id="{5BCAD085-E8A6-8845-BD4E-CB4CCA059FC4}" type="datetimeFigureOut">
               <a:rPr lang="en-US" smtClean="0"/>
-              <a:t>1/27/13</a:t>
+              <a:t>9/27/2026</a:t>
             </a:fld>
             <a:endParaRPr lang="en-US"/>
           </a:p>
@@ -920,10 +929,9 @@
           </a:lstStyle>
           <a:p>
             <a:r>
-              <a:rPr lang="en-US" smtClean="0"/>
+              <a:rPr lang="en-US"/>
               <a:t>Click to edit Master title style</a:t>
             </a:r>
-            <a:endParaRPr lang="en-US"/>
           </a:p>
         </p:txBody>
       </p:sp>
@@ -1040,7 +1048,7 @@
           <a:p>
             <a:pPr lvl="0"/>
             <a:r>
-              <a:rPr lang="en-US" smtClean="0"/>
+              <a:rPr lang="en-US"/>
               <a:t>Click to edit Master text styles</a:t>
             </a:r>
           </a:p>
@@ -1063,7 +1071,7 @@
           <a:p>
             <a:fld id="{5BCAD085-E8A6-8845-BD4E-CB4CCA059FC4}" type="datetimeFigureOut">
               <a:rPr lang="en-US" smtClean="0"/>
-              <a:t>1/27/13</a:t>
+              <a:t>9/27/2026</a:t>
             </a:fld>
             <a:endParaRPr lang="en-US"/>
           </a:p>
@@ -1157,10 +1165,9 @@
           <a:lstStyle/>
           <a:p>
             <a:r>
-              <a:rPr lang="en-US" smtClean="0"/>
+              <a:rPr lang="en-US"/>
               <a:t>Click to edit Master title style</a:t>
             </a:r>
-            <a:endParaRPr lang="en-US"/>
           </a:p>
         </p:txBody>
       </p:sp>
@@ -1214,38 +1221,37 @@
           <a:p>
             <a:pPr lvl="0"/>
             <a:r>
-              <a:rPr lang="en-US" smtClean="0"/>
+              <a:rPr lang="en-US"/>
               <a:t>Click to edit Master text styles</a:t>
             </a:r>
           </a:p>
           <a:p>
             <a:pPr lvl="1"/>
             <a:r>
-              <a:rPr lang="en-US" smtClean="0"/>
+              <a:rPr lang="en-US"/>
               <a:t>Second level</a:t>
             </a:r>
           </a:p>
           <a:p>
             <a:pPr lvl="2"/>
             <a:r>
-              <a:rPr lang="en-US" smtClean="0"/>
+              <a:rPr lang="en-US"/>
               <a:t>Third level</a:t>
             </a:r>
           </a:p>
           <a:p>
             <a:pPr lvl="3"/>
             <a:r>
-              <a:rPr lang="en-US" smtClean="0"/>
+              <a:rPr lang="en-US"/>
               <a:t>Fourth level</a:t>
             </a:r>
           </a:p>
           <a:p>
             <a:pPr lvl="4"/>
             <a:r>
-              <a:rPr lang="en-US" smtClean="0"/>
+              <a:rPr lang="en-US"/>
               <a:t>Fifth level</a:t>
             </a:r>
-            <a:endParaRPr lang="en-US"/>
           </a:p>
         </p:txBody>
       </p:sp>
@@ -1299,38 +1305,37 @@
           <a:p>
             <a:pPr lvl="0"/>
             <a:r>
-              <a:rPr lang="en-US" smtClean="0"/>
+              <a:rPr lang="en-US"/>
               <a:t>Click to edit Master text styles</a:t>
             </a:r>
           </a:p>
           <a:p>
             <a:pPr lvl="1"/>
             <a:r>
-              <a:rPr lang="en-US" smtClean="0"/>
+              <a:rPr lang="en-US"/>
               <a:t>Second level</a:t>
             </a:r>
           </a:p>
           <a:p>
             <a:pPr lvl="2"/>
             <a:r>
-              <a:rPr lang="en-US" smtClean="0"/>
+              <a:rPr lang="en-US"/>
               <a:t>Third level</a:t>
             </a:r>
           </a:p>
           <a:p>
             <a:pPr lvl="3"/>
             <a:r>
-              <a:rPr lang="en-US" smtClean="0"/>
+              <a:rPr lang="en-US"/>
               <a:t>Fourth level</a:t>
             </a:r>
           </a:p>
           <a:p>
             <a:pPr lvl="4"/>
             <a:r>
-              <a:rPr lang="en-US" smtClean="0"/>
+              <a:rPr lang="en-US"/>
               <a:t>Fifth level</a:t>
             </a:r>
-            <a:endParaRPr lang="en-US"/>
           </a:p>
         </p:txBody>
       </p:sp>
@@ -1351,7 +1356,7 @@
           <a:p>
             <a:fld id="{5BCAD085-E8A6-8845-BD4E-CB4CCA059FC4}" type="datetimeFigureOut">
               <a:rPr lang="en-US" smtClean="0"/>
-              <a:t>1/27/13</a:t>
+              <a:t>9/27/2026</a:t>
             </a:fld>
             <a:endParaRPr lang="en-US"/>
           </a:p>
@@ -1449,10 +1454,9 @@
           </a:lstStyle>
           <a:p>
             <a:r>
-              <a:rPr lang="en-US" smtClean="0"/>
+              <a:rPr lang="en-US"/>
               <a:t>Click to edit Master title style</a:t>
             </a:r>
-            <a:endParaRPr lang="en-US"/>
           </a:p>
         </p:txBody>
       </p:sp>
@@ -1515,7 +1519,7 @@
           <a:p>
             <a:pPr lvl="0"/>
             <a:r>
-              <a:rPr lang="en-US" smtClean="0"/>
+              <a:rPr lang="en-US"/>
               <a:t>Click to edit Master text styles</a:t>
             </a:r>
           </a:p>
@@ -1571,38 +1575,37 @@
           <a:p>
             <a:pPr lvl="0"/>
             <a:r>
-              <a:rPr lang="en-US" smtClean="0"/>
+              <a:rPr lang="en-US"/>
               <a:t>Click to edit Master text styles</a:t>
             </a:r>
           </a:p>
           <a:p>
             <a:pPr lvl="1"/>
             <a:r>
-              <a:rPr lang="en-US" smtClean="0"/>
+              <a:rPr lang="en-US"/>
               <a:t>Second level</a:t>
             </a:r>
           </a:p>
           <a:p>
             <a:pPr lvl="2"/>
             <a:r>
-              <a:rPr lang="en-US" smtClean="0"/>
+              <a:rPr lang="en-US"/>
               <a:t>Third level</a:t>
             </a:r>
           </a:p>
           <a:p>
             <a:pPr lvl="3"/>
             <a:r>
-              <a:rPr lang="en-US" smtClean="0"/>
+              <a:rPr lang="en-US"/>
               <a:t>Fourth level</a:t>
             </a:r>
           </a:p>
           <a:p>
             <a:pPr lvl="4"/>
             <a:r>
-              <a:rPr lang="en-US" smtClean="0"/>
+              <a:rPr lang="en-US"/>
               <a:t>Fifth level</a:t>
             </a:r>
-            <a:endParaRPr lang="en-US"/>
           </a:p>
         </p:txBody>
       </p:sp>
@@ -1665,7 +1668,7 @@
           <a:p>
             <a:pPr lvl="0"/>
             <a:r>
-              <a:rPr lang="en-US" smtClean="0"/>
+              <a:rPr lang="en-US"/>
               <a:t>Click to edit Master text styles</a:t>
             </a:r>
           </a:p>
@@ -1721,38 +1724,37 @@
           <a:p>
             <a:pPr lvl="0"/>
             <a:r>
-              <a:rPr lang="en-US" smtClean="0"/>
+              <a:rPr lang="en-US"/>
               <a:t>Click to edit Master text styles</a:t>
             </a:r>
           </a:p>
           <a:p>
             <a:pPr lvl="1"/>
             <a:r>
-              <a:rPr lang="en-US" smtClean="0"/>
+              <a:rPr lang="en-US"/>
               <a:t>Second level</a:t>
             </a:r>
           </a:p>
           <a:p>
             <a:pPr lvl="2"/>
             <a:r>
-              <a:rPr lang="en-US" smtClean="0"/>
+              <a:rPr lang="en-US"/>
               <a:t>Third level</a:t>
             </a:r>
           </a:p>
           <a:p>
             <a:pPr lvl="3"/>
             <a:r>
-              <a:rPr lang="en-US" smtClean="0"/>
+              <a:rPr lang="en-US"/>
               <a:t>Fourth level</a:t>
             </a:r>
           </a:p>
           <a:p>
             <a:pPr lvl="4"/>
             <a:r>
-              <a:rPr lang="en-US" smtClean="0"/>
+              <a:rPr lang="en-US"/>
               <a:t>Fifth level</a:t>
             </a:r>
-            <a:endParaRPr lang="en-US"/>
           </a:p>
         </p:txBody>
       </p:sp>
@@ -1773,7 +1775,7 @@
           <a:p>
             <a:fld id="{5BCAD085-E8A6-8845-BD4E-CB4CCA059FC4}" type="datetimeFigureOut">
               <a:rPr lang="en-US" smtClean="0"/>
-              <a:t>1/27/13</a:t>
+              <a:t>9/27/2026</a:t>
             </a:fld>
             <a:endParaRPr lang="en-US"/>
           </a:p>
@@ -1867,10 +1869,9 @@
           <a:lstStyle/>
           <a:p>
             <a:r>
-              <a:rPr lang="en-US" smtClean="0"/>
+              <a:rPr lang="en-US"/>
               <a:t>Click to edit Master title style</a:t>
             </a:r>
-            <a:endParaRPr lang="en-US"/>
           </a:p>
         </p:txBody>
       </p:sp>
@@ -1891,7 +1892,7 @@
           <a:p>
             <a:fld id="{5BCAD085-E8A6-8845-BD4E-CB4CCA059FC4}" type="datetimeFigureOut">
               <a:rPr lang="en-US" smtClean="0"/>
-              <a:t>1/27/13</a:t>
+              <a:t>9/27/2026</a:t>
             </a:fld>
             <a:endParaRPr lang="en-US"/>
           </a:p>
@@ -1986,7 +1987,7 @@
           <a:p>
             <a:fld id="{5BCAD085-E8A6-8845-BD4E-CB4CCA059FC4}" type="datetimeFigureOut">
               <a:rPr lang="en-US" smtClean="0"/>
-              <a:t>1/27/13</a:t>
+              <a:t>9/27/2026</a:t>
             </a:fld>
             <a:endParaRPr lang="en-US"/>
           </a:p>
@@ -2089,10 +2090,9 @@
           </a:lstStyle>
           <a:p>
             <a:r>
-              <a:rPr lang="en-US" smtClean="0"/>
+              <a:rPr lang="en-US"/>
               <a:t>Click to edit Master title style</a:t>
             </a:r>
-            <a:endParaRPr lang="en-US"/>
           </a:p>
         </p:txBody>
       </p:sp>
@@ -2146,38 +2146,37 @@
           <a:p>
             <a:pPr lvl="0"/>
             <a:r>
-              <a:rPr lang="en-US" smtClean="0"/>
+              <a:rPr lang="en-US"/>
               <a:t>Click to edit Master text styles</a:t>
             </a:r>
           </a:p>
           <a:p>
             <a:pPr lvl="1"/>
             <a:r>
-              <a:rPr lang="en-US" smtClean="0"/>
+              <a:rPr lang="en-US"/>
               <a:t>Second level</a:t>
             </a:r>
           </a:p>
           <a:p>
             <a:pPr lvl="2"/>
             <a:r>
-              <a:rPr lang="en-US" smtClean="0"/>
+              <a:rPr lang="en-US"/>
               <a:t>Third level</a:t>
             </a:r>
           </a:p>
           <a:p>
             <a:pPr lvl="3"/>
             <a:r>
-              <a:rPr lang="en-US" smtClean="0"/>
+              <a:rPr lang="en-US"/>
               <a:t>Fourth level</a:t>
             </a:r>
           </a:p>
           <a:p>
             <a:pPr lvl="4"/>
             <a:r>
-              <a:rPr lang="en-US" smtClean="0"/>
+              <a:rPr lang="en-US"/>
               <a:t>Fifth level</a:t>
             </a:r>
-            <a:endParaRPr lang="en-US"/>
           </a:p>
         </p:txBody>
       </p:sp>
@@ -2240,7 +2239,7 @@
           <a:p>
             <a:pPr lvl="0"/>
             <a:r>
-              <a:rPr lang="en-US" smtClean="0"/>
+              <a:rPr lang="en-US"/>
               <a:t>Click to edit Master text styles</a:t>
             </a:r>
           </a:p>
@@ -2263,7 +2262,7 @@
           <a:p>
             <a:fld id="{5BCAD085-E8A6-8845-BD4E-CB4CCA059FC4}" type="datetimeFigureOut">
               <a:rPr lang="en-US" smtClean="0"/>
-              <a:t>1/27/13</a:t>
+              <a:t>9/27/2026</a:t>
             </a:fld>
             <a:endParaRPr lang="en-US"/>
           </a:p>
@@ -2366,10 +2365,9 @@
           </a:lstStyle>
           <a:p>
             <a:r>
-              <a:rPr lang="en-US" smtClean="0"/>
+              <a:rPr lang="en-US"/>
               <a:t>Click to edit Master title style</a:t>
             </a:r>
-            <a:endParaRPr lang="en-US"/>
           </a:p>
         </p:txBody>
       </p:sp>
@@ -2493,7 +2491,7 @@
           <a:p>
             <a:pPr lvl="0"/>
             <a:r>
-              <a:rPr lang="en-US" smtClean="0"/>
+              <a:rPr lang="en-US"/>
               <a:t>Click to edit Master text styles</a:t>
             </a:r>
           </a:p>
@@ -2516,7 +2514,7 @@
           <a:p>
             <a:fld id="{5BCAD085-E8A6-8845-BD4E-CB4CCA059FC4}" type="datetimeFigureOut">
               <a:rPr lang="en-US" smtClean="0"/>
-              <a:t>1/27/13</a:t>
+              <a:t>9/27/2026</a:t>
             </a:fld>
             <a:endParaRPr lang="en-US"/>
           </a:p>
@@ -2625,10 +2623,9 @@
           <a:lstStyle/>
           <a:p>
             <a:r>
-              <a:rPr lang="en-US" smtClean="0"/>
+              <a:rPr lang="en-US"/>
               <a:t>Click to edit Master title style</a:t>
             </a:r>
-            <a:endParaRPr lang="en-US"/>
           </a:p>
         </p:txBody>
       </p:sp>
@@ -2659,38 +2656,37 @@
           <a:p>
             <a:pPr lvl="0"/>
             <a:r>
-              <a:rPr lang="en-US" smtClean="0"/>
+              <a:rPr lang="en-US"/>
               <a:t>Click to edit Master text styles</a:t>
             </a:r>
           </a:p>
           <a:p>
             <a:pPr lvl="1"/>
             <a:r>
-              <a:rPr lang="en-US" smtClean="0"/>
+              <a:rPr lang="en-US"/>
               <a:t>Second level</a:t>
             </a:r>
           </a:p>
           <a:p>
             <a:pPr lvl="2"/>
             <a:r>
-              <a:rPr lang="en-US" smtClean="0"/>
+              <a:rPr lang="en-US"/>
               <a:t>Third level</a:t>
             </a:r>
           </a:p>
           <a:p>
             <a:pPr lvl="3"/>
             <a:r>
-              <a:rPr lang="en-US" smtClean="0"/>
+              <a:rPr lang="en-US"/>
               <a:t>Fourth level</a:t>
             </a:r>
           </a:p>
           <a:p>
             <a:pPr lvl="4"/>
             <a:r>
-              <a:rPr lang="en-US" smtClean="0"/>
+              <a:rPr lang="en-US"/>
               <a:t>Fifth level</a:t>
             </a:r>
-            <a:endParaRPr lang="en-US"/>
           </a:p>
         </p:txBody>
       </p:sp>
@@ -2729,7 +2725,7 @@
           <a:p>
             <a:fld id="{5BCAD085-E8A6-8845-BD4E-CB4CCA059FC4}" type="datetimeFigureOut">
               <a:rPr lang="en-US" smtClean="0"/>
-              <a:t>1/27/13</a:t>
+              <a:t>9/27/2026</a:t>
             </a:fld>
             <a:endParaRPr lang="en-US"/>
           </a:p>
@@ -3088,7 +3084,7 @@
 </file>
 
 <file path=ppt/slides/slide1.xml><?xml version="1.0" encoding="utf-8"?>
-<p:sld xmlns:a="http://schemas.openxmlformats.org/drawingml/2006/main" xmlns:p="http://schemas.openxmlformats.org/presentationml/2006/main" xmlns:r="http://schemas.openxmlformats.org/officeDocument/2006/relationships">
+<p:sld xmlns:a="http://schemas.openxmlformats.org/drawingml/2006/main" xmlns:r="http://schemas.openxmlformats.org/officeDocument/2006/relationships" xmlns:p="http://schemas.openxmlformats.org/presentationml/2006/main">
   <p:cSld>
     <p:bg>
       <p:bgPr>
@@ -3104,7 +3100,14 @@
         <p:cNvGrpSpPr/>
         <p:nvPr/>
       </p:nvGrpSpPr>
-      <p:grpSpPr/>
+      <p:grpSpPr>
+        <a:xfrm>
+          <a:off x="0" y="0"/>
+          <a:ext cx="0" cy="0"/>
+          <a:chOff x="0" y="0"/>
+          <a:chExt cx="0" cy="0"/>
+        </a:xfrm>
+      </p:grpSpPr>
       <p:sp>
         <p:nvSpPr>
           <p:cNvPr id="2" name="Rectangle 1"/>
@@ -3147,6 +3150,7 @@
           <a:lstStyle/>
           <a:p>
             <a:pPr algn="ctr"/>
+            <a:endParaRPr/>
           </a:p>
         </p:txBody>
       </p:sp>
@@ -3167,7 +3171,7 @@
           <a:noFill/>
         </p:spPr>
         <p:txBody>
-          <a:bodyPr wrap="square" lIns="27432" rIns="27432" tIns="27432" bIns="27432" anchor="t">
+          <a:bodyPr wrap="square" lIns="27432" tIns="27432" rIns="27432" bIns="27432" anchor="t">
             <a:spAutoFit/>
           </a:bodyPr>
           <a:lstStyle/>
@@ -3206,7 +3210,7 @@
           <a:noFill/>
         </p:spPr>
         <p:txBody>
-          <a:bodyPr wrap="square" lIns="27432" rIns="27432" tIns="27432" bIns="27432" anchor="t">
+          <a:bodyPr wrap="square" lIns="27432" tIns="27432" rIns="27432" bIns="27432" anchor="t">
             <a:spAutoFit/>
           </a:bodyPr>
           <a:lstStyle/>
@@ -3245,7 +3249,7 @@
           <a:noFill/>
         </p:spPr>
         <p:txBody>
-          <a:bodyPr wrap="square" lIns="27432" rIns="27432" tIns="27432" bIns="27432" anchor="t">
+          <a:bodyPr wrap="square" lIns="27432" tIns="27432" rIns="27432" bIns="27432" anchor="t">
             <a:spAutoFit/>
           </a:bodyPr>
           <a:lstStyle/>
@@ -3309,6 +3313,7 @@
           <a:lstStyle/>
           <a:p>
             <a:pPr algn="ctr"/>
+            <a:endParaRPr/>
           </a:p>
         </p:txBody>
       </p:sp>
@@ -3354,6 +3359,7 @@
           <a:lstStyle/>
           <a:p>
             <a:pPr algn="ctr"/>
+            <a:endParaRPr/>
           </a:p>
         </p:txBody>
       </p:sp>
@@ -3374,7 +3380,7 @@
           <a:noFill/>
         </p:spPr>
         <p:txBody>
-          <a:bodyPr wrap="square" lIns="27432" rIns="27432" tIns="27432" bIns="27432" anchor="t">
+          <a:bodyPr wrap="square" lIns="27432" tIns="27432" rIns="27432" bIns="27432" anchor="t">
             <a:spAutoFit/>
           </a:bodyPr>
           <a:lstStyle/>
@@ -3413,7 +3419,7 @@
           <a:noFill/>
         </p:spPr>
         <p:txBody>
-          <a:bodyPr wrap="square" lIns="27432" rIns="27432" tIns="27432" bIns="27432" anchor="t">
+          <a:bodyPr wrap="square" lIns="27432" tIns="27432" rIns="27432" bIns="27432" anchor="t">
             <a:spAutoFit/>
           </a:bodyPr>
           <a:lstStyle/>
@@ -3444,7 +3450,7 @@
         <p:spPr>
           <a:xfrm>
             <a:off x="658368" y="1828800"/>
-            <a:ext cx="91440" cy="3017520"/>
+            <a:ext cx="54864" cy="3756356"/>
           </a:xfrm>
           <a:prstGeom prst="rect">
             <a:avLst/>
@@ -3477,6 +3483,7 @@
           <a:lstStyle/>
           <a:p>
             <a:pPr algn="ctr"/>
+            <a:endParaRPr/>
           </a:p>
         </p:txBody>
       </p:sp>
@@ -3497,7 +3504,7 @@
           <a:noFill/>
         </p:spPr>
         <p:txBody>
-          <a:bodyPr wrap="square" lIns="27432" rIns="27432" tIns="27432" bIns="27432" anchor="t">
+          <a:bodyPr wrap="square" lIns="27432" tIns="27432" rIns="27432" bIns="27432" anchor="t">
             <a:spAutoFit/>
           </a:bodyPr>
           <a:lstStyle/>
@@ -3543,7 +3550,7 @@
         </p:nvSpPr>
         <p:spPr>
           <a:xfrm>
-            <a:off x="978408" y="3236976"/>
+            <a:off x="978408" y="3135478"/>
             <a:ext cx="9784080" cy="411480"/>
           </a:xfrm>
           <a:prstGeom prst="rect">
@@ -3552,7 +3559,7 @@
           <a:noFill/>
         </p:spPr>
         <p:txBody>
-          <a:bodyPr wrap="square" lIns="27432" rIns="27432" tIns="27432" bIns="27432" anchor="t">
+          <a:bodyPr wrap="square" lIns="27432" tIns="27432" rIns="27432" bIns="27432" anchor="t">
             <a:spAutoFit/>
           </a:bodyPr>
           <a:lstStyle/>
@@ -3569,6 +3576,7 @@
               </a:defRPr>
             </a:pPr>
             <a:r>
+              <a:rPr dirty="0"/>
               <a:t>Proof you can inspect. Skills you can trust.</a:t>
             </a:r>
           </a:p>
@@ -3582,8 +3590,8 @@
         </p:nvSpPr>
         <p:spPr>
           <a:xfrm>
-            <a:off x="978408" y="3840480"/>
-            <a:ext cx="9966960" cy="411480"/>
+            <a:off x="1316736" y="3525806"/>
+            <a:ext cx="9966960" cy="1294200"/>
           </a:xfrm>
           <a:prstGeom prst="rect">
             <a:avLst/>
@@ -3591,7 +3599,7 @@
           <a:noFill/>
         </p:spPr>
         <p:txBody>
-          <a:bodyPr wrap="square" lIns="27432" rIns="27432" tIns="27432" bIns="27432" anchor="t">
+          <a:bodyPr wrap="square" lIns="27432" tIns="27432" rIns="27432" bIns="27432" anchor="t">
             <a:spAutoFit/>
           </a:bodyPr>
           <a:lstStyle/>
@@ -3608,8 +3616,94 @@
               </a:defRPr>
             </a:pPr>
             <a:r>
-              <a:t>Team HM26-C3B5  ·  Members: [add names]  ·  Colleges: [add colleges]</a:t>
-            </a:r>
+              <a:rPr dirty="0"/>
+              <a:t>Team HM26-C3B5  ·  </a:t>
+            </a:r>
+            <a:r>
+              <a:rPr lang="en-US" dirty="0"/>
+              <a:t> </a:t>
+            </a:r>
+            <a:r>
+              <a:rPr dirty="0"/>
+              <a:t>Members: [</a:t>
+            </a:r>
+            <a:r>
+              <a:rPr lang="en-US" dirty="0"/>
+              <a:t> YOGESH S </a:t>
+            </a:r>
+            <a:r>
+              <a:rPr dirty="0"/>
+              <a:t>]  </a:t>
+            </a:r>
+            <a:r>
+              <a:rPr lang="en-US" dirty="0"/>
+              <a:t>           </a:t>
+            </a:r>
+            <a:r>
+              <a:rPr dirty="0"/>
+              <a:t>·  Colleges: [</a:t>
+            </a:r>
+            <a:r>
+              <a:rPr lang="en-US" dirty="0"/>
+              <a:t> Amrita School Of Computing</a:t>
+            </a:r>
+            <a:r>
+              <a:rPr dirty="0"/>
+              <a:t>]</a:t>
+            </a:r>
+            <a:endParaRPr lang="en-US" dirty="0"/>
+          </a:p>
+          <a:p>
+            <a:pPr>
+              <a:spcAft>
+                <a:spcPts val="500"/>
+              </a:spcAft>
+              <a:defRPr sz="1700" b="0">
+                <a:solidFill>
+                  <a:srgbClr val="25332C"/>
+                </a:solidFill>
+                <a:latin typeface="Aptos"/>
+              </a:defRPr>
+            </a:pPr>
+            <a:r>
+              <a:rPr lang="en-US" dirty="0"/>
+              <a:t>                                        ·   Members: [AMAL ]                        ·  Colleges: [ Jain Deemed to be University ]</a:t>
+            </a:r>
+          </a:p>
+          <a:p>
+            <a:pPr>
+              <a:spcAft>
+                <a:spcPts val="500"/>
+              </a:spcAft>
+              <a:defRPr sz="1700" b="0">
+                <a:solidFill>
+                  <a:srgbClr val="25332C"/>
+                </a:solidFill>
+                <a:latin typeface="Aptos"/>
+              </a:defRPr>
+            </a:pPr>
+            <a:r>
+              <a:rPr lang="en-US" dirty="0"/>
+              <a:t>                                        ·   Members: [ NISHKALA  G B ]    ·  Colleges: [Amrita School Of Computing]</a:t>
+            </a:r>
+          </a:p>
+          <a:p>
+            <a:pPr>
+              <a:spcAft>
+                <a:spcPts val="500"/>
+              </a:spcAft>
+              <a:defRPr sz="1700" b="0">
+                <a:solidFill>
+                  <a:srgbClr val="25332C"/>
+                </a:solidFill>
+                <a:latin typeface="Aptos"/>
+              </a:defRPr>
+            </a:pPr>
+            <a:r>
+              <a:rPr lang="en-US" dirty="0"/>
+              <a:t>         </a:t>
+            </a:r>
+            <a:endParaRPr dirty="0"/>
           </a:p>
         </p:txBody>
       </p:sp>
@@ -3621,7 +3715,7 @@
         </p:nvSpPr>
         <p:spPr>
           <a:xfrm>
-            <a:off x="978408" y="4389120"/>
+            <a:off x="978408" y="5104638"/>
             <a:ext cx="9966960" cy="365760"/>
           </a:xfrm>
           <a:prstGeom prst="rect">
@@ -3630,7 +3724,7 @@
           <a:noFill/>
         </p:spPr>
         <p:txBody>
-          <a:bodyPr wrap="square" lIns="27432" rIns="27432" tIns="27432" bIns="27432" anchor="t">
+          <a:bodyPr wrap="square" lIns="27432" tIns="27432" rIns="27432" bIns="27432" anchor="t">
             <a:spAutoFit/>
           </a:bodyPr>
           <a:lstStyle/>
@@ -3647,6 +3741,7 @@
               </a:defRPr>
             </a:pPr>
             <a:r>
+              <a:rPr dirty="0"/>
               <a:t>Selected problem · The proof gap in cybersecurity hiring</a:t>
             </a:r>
           </a:p>
@@ -3661,7 +3756,111 @@
 </file>
 
 <file path=ppt/slides/slide10.xml><?xml version="1.0" encoding="utf-8"?>
-<p:sld xmlns:a="http://schemas.openxmlformats.org/drawingml/2006/main" xmlns:p="http://schemas.openxmlformats.org/presentationml/2006/main" xmlns:r="http://schemas.openxmlformats.org/officeDocument/2006/relationships">
+<p:sld xmlns:a="http://schemas.openxmlformats.org/drawingml/2006/main" xmlns:r="http://schemas.openxmlformats.org/officeDocument/2006/relationships" xmlns:p="http://schemas.openxmlformats.org/presentationml/2006/main">
+  <p:cSld>
+    <p:bg>
+      <p:bgPr>
+        <a:solidFill>
+          <a:srgbClr val="F7F7F2"/>
+        </a:solidFill>
+        <a:effectLst/>
+      </p:bgPr>
+    </p:bg>
+    <p:spTree>
+      <p:nvGrpSpPr>
+        <p:cNvPr id="1" name="">
+          <a:extLst>
+            <a:ext uri="{FF2B5EF4-FFF2-40B4-BE49-F238E27FC236}">
+              <a16:creationId xmlns:a16="http://schemas.microsoft.com/office/drawing/2014/main" id="{BFB69E96-B248-C803-31C2-27F497F2416B}"/>
+            </a:ext>
+          </a:extLst>
+        </p:cNvPr>
+        <p:cNvGrpSpPr/>
+        <p:nvPr/>
+      </p:nvGrpSpPr>
+      <p:grpSpPr>
+        <a:xfrm>
+          <a:off x="0" y="0"/>
+          <a:ext cx="0" cy="0"/>
+          <a:chOff x="0" y="0"/>
+          <a:chExt cx="0" cy="0"/>
+        </a:xfrm>
+      </p:grpSpPr>
+      <p:pic>
+        <p:nvPicPr>
+          <p:cNvPr id="20" name="Picture 19">
+            <a:extLst>
+              <a:ext uri="{FF2B5EF4-FFF2-40B4-BE49-F238E27FC236}">
+                <a16:creationId xmlns:a16="http://schemas.microsoft.com/office/drawing/2014/main" id="{2B7FD95D-9CCC-5FC1-DB81-848DBF254F3E}"/>
+              </a:ext>
+            </a:extLst>
+          </p:cNvPr>
+          <p:cNvPicPr>
+            <a:picLocks noChangeAspect="1"/>
+          </p:cNvPicPr>
+          <p:nvPr/>
+        </p:nvPicPr>
+        <p:blipFill>
+          <a:blip r:embed="rId2"/>
+          <a:stretch>
+            <a:fillRect/>
+          </a:stretch>
+        </p:blipFill>
+        <p:spPr>
+          <a:xfrm>
+            <a:off x="0" y="163172"/>
+            <a:ext cx="12192000" cy="6531656"/>
+          </a:xfrm>
+          <a:prstGeom prst="rect">
+            <a:avLst/>
+          </a:prstGeom>
+        </p:spPr>
+      </p:pic>
+      <p:pic>
+        <p:nvPicPr>
+          <p:cNvPr id="3" name="Picture 2">
+            <a:extLst>
+              <a:ext uri="{FF2B5EF4-FFF2-40B4-BE49-F238E27FC236}">
+                <a16:creationId xmlns:a16="http://schemas.microsoft.com/office/drawing/2014/main" id="{2F0B2A0F-5C64-B10F-95D9-738BFCCC2C39}"/>
+              </a:ext>
+            </a:extLst>
+          </p:cNvPr>
+          <p:cNvPicPr>
+            <a:picLocks noChangeAspect="1"/>
+          </p:cNvPicPr>
+          <p:nvPr/>
+        </p:nvPicPr>
+        <p:blipFill>
+          <a:blip r:embed="rId3"/>
+          <a:stretch>
+            <a:fillRect/>
+          </a:stretch>
+        </p:blipFill>
+        <p:spPr>
+          <a:xfrm>
+            <a:off x="0" y="993"/>
+            <a:ext cx="12192000" cy="6856013"/>
+          </a:xfrm>
+          <a:prstGeom prst="rect">
+            <a:avLst/>
+          </a:prstGeom>
+        </p:spPr>
+      </p:pic>
+    </p:spTree>
+    <p:extLst>
+      <p:ext uri="{BB962C8B-B14F-4D97-AF65-F5344CB8AC3E}">
+        <p14:creationId xmlns:p14="http://schemas.microsoft.com/office/powerpoint/2010/main" val="1443955805"/>
+      </p:ext>
+    </p:extLst>
+  </p:cSld>
+  <p:clrMapOvr>
+    <a:masterClrMapping/>
+  </p:clrMapOvr>
+</p:sld>
+</file>
+
+<file path=ppt/slides/slide11.xml><?xml version="1.0" encoding="utf-8"?>
+<p:sld xmlns:a="http://schemas.openxmlformats.org/drawingml/2006/main" xmlns:r="http://schemas.openxmlformats.org/officeDocument/2006/relationships" xmlns:p="http://schemas.openxmlformats.org/presentationml/2006/main">
   <p:cSld>
     <p:bg>
       <p:bgPr>
@@ -3677,7 +3876,14 @@
         <p:cNvGrpSpPr/>
         <p:nvPr/>
       </p:nvGrpSpPr>
-      <p:grpSpPr/>
+      <p:grpSpPr>
+        <a:xfrm>
+          <a:off x="0" y="0"/>
+          <a:ext cx="0" cy="0"/>
+          <a:chOff x="0" y="0"/>
+          <a:chExt cx="0" cy="0"/>
+        </a:xfrm>
+      </p:grpSpPr>
       <p:sp>
         <p:nvSpPr>
           <p:cNvPr id="2" name="Rectangle 1"/>
@@ -3720,6 +3926,7 @@
           <a:lstStyle/>
           <a:p>
             <a:pPr algn="ctr"/>
+            <a:endParaRPr/>
           </a:p>
         </p:txBody>
       </p:sp>
@@ -3740,7 +3947,7 @@
           <a:noFill/>
         </p:spPr>
         <p:txBody>
-          <a:bodyPr wrap="square" lIns="27432" rIns="27432" tIns="27432" bIns="27432" anchor="t">
+          <a:bodyPr wrap="square" lIns="27432" tIns="27432" rIns="27432" bIns="27432" anchor="t">
             <a:spAutoFit/>
           </a:bodyPr>
           <a:lstStyle/>
@@ -3779,7 +3986,7 @@
           <a:noFill/>
         </p:spPr>
         <p:txBody>
-          <a:bodyPr wrap="square" lIns="27432" rIns="27432" tIns="27432" bIns="27432" anchor="t">
+          <a:bodyPr wrap="square" lIns="27432" tIns="27432" rIns="27432" bIns="27432" anchor="t">
             <a:spAutoFit/>
           </a:bodyPr>
           <a:lstStyle/>
@@ -3818,7 +4025,7 @@
           <a:noFill/>
         </p:spPr>
         <p:txBody>
-          <a:bodyPr wrap="square" lIns="27432" rIns="27432" tIns="27432" bIns="27432" anchor="t">
+          <a:bodyPr wrap="square" lIns="27432" tIns="27432" rIns="27432" bIns="27432" anchor="t">
             <a:spAutoFit/>
           </a:bodyPr>
           <a:lstStyle/>
@@ -3882,6 +4089,7 @@
           <a:lstStyle/>
           <a:p>
             <a:pPr algn="ctr"/>
+            <a:endParaRPr/>
           </a:p>
         </p:txBody>
       </p:sp>
@@ -3927,6 +4135,7 @@
           <a:lstStyle/>
           <a:p>
             <a:pPr algn="ctr"/>
+            <a:endParaRPr/>
           </a:p>
         </p:txBody>
       </p:sp>
@@ -3947,7 +4156,7 @@
           <a:noFill/>
         </p:spPr>
         <p:txBody>
-          <a:bodyPr wrap="square" lIns="27432" rIns="27432" tIns="27432" bIns="27432" anchor="t">
+          <a:bodyPr wrap="square" lIns="27432" tIns="27432" rIns="27432" bIns="27432" anchor="t">
             <a:spAutoFit/>
           </a:bodyPr>
           <a:lstStyle/>
@@ -3986,7 +4195,7 @@
           <a:noFill/>
         </p:spPr>
         <p:txBody>
-          <a:bodyPr wrap="square" lIns="27432" rIns="27432" tIns="27432" bIns="27432" anchor="t">
+          <a:bodyPr wrap="square" lIns="27432" tIns="27432" rIns="27432" bIns="27432" anchor="t">
             <a:spAutoFit/>
           </a:bodyPr>
           <a:lstStyle/>
@@ -4025,7 +4234,7 @@
           <a:noFill/>
         </p:spPr>
         <p:txBody>
-          <a:bodyPr wrap="square" lIns="27432" rIns="27432" tIns="27432" bIns="27432" anchor="t">
+          <a:bodyPr wrap="square" lIns="27432" tIns="27432" rIns="27432" bIns="27432" anchor="t">
             <a:spAutoFit/>
           </a:bodyPr>
           <a:lstStyle/>
@@ -4064,7 +4273,7 @@
           <a:noFill/>
         </p:spPr>
         <p:txBody>
-          <a:bodyPr wrap="square" lIns="27432" rIns="27432" tIns="27432" bIns="27432" anchor="t">
+          <a:bodyPr wrap="square" lIns="27432" tIns="27432" rIns="27432" bIns="27432" anchor="t">
             <a:spAutoFit/>
           </a:bodyPr>
           <a:lstStyle/>
@@ -4103,7 +4312,7 @@
           <a:noFill/>
         </p:spPr>
         <p:txBody>
-          <a:bodyPr wrap="square" lIns="27432" rIns="27432" tIns="27432" bIns="27432" anchor="t">
+          <a:bodyPr wrap="square" lIns="27432" tIns="27432" rIns="27432" bIns="27432" anchor="t">
             <a:spAutoFit/>
           </a:bodyPr>
           <a:lstStyle/>
@@ -4142,7 +4351,7 @@
           <a:noFill/>
         </p:spPr>
         <p:txBody>
-          <a:bodyPr wrap="square" lIns="27432" rIns="27432" tIns="27432" bIns="27432" anchor="t">
+          <a:bodyPr wrap="square" lIns="27432" tIns="27432" rIns="27432" bIns="27432" anchor="t">
             <a:spAutoFit/>
           </a:bodyPr>
           <a:lstStyle/>
@@ -4208,204 +4417,191 @@
           <a:lstStyle/>
           <a:p>
             <a:pPr algn="ctr"/>
-          </a:p>
-        </p:txBody>
-      </p:sp>
-      <p:sp>
-        <p:nvSpPr>
-          <p:cNvPr id="15" name="TextBox 14"/>
-          <p:cNvSpPr txBox="1"/>
-          <p:nvPr/>
-        </p:nvSpPr>
-        <p:spPr>
-          <a:xfrm>
-            <a:off x="914400" y="4754880"/>
-            <a:ext cx="1371600" cy="228600"/>
-          </a:xfrm>
-          <a:prstGeom prst="rect">
-            <a:avLst/>
-          </a:prstGeom>
-          <a:noFill/>
-        </p:spPr>
-        <p:txBody>
-          <a:bodyPr wrap="square" lIns="27432" rIns="27432" tIns="27432" bIns="27432" anchor="t">
-            <a:spAutoFit/>
-          </a:bodyPr>
-          <a:lstStyle/>
-          <a:p>
-            <a:pPr algn="l">
-              <a:spcAft>
-                <a:spcPts val="500"/>
-              </a:spcAft>
-              <a:defRPr sz="1300" b="1">
-                <a:solidFill>
-                  <a:srgbClr val="24563E"/>
-                </a:solidFill>
-                <a:latin typeface="Aptos"/>
-              </a:defRPr>
-            </a:pPr>
-            <a:r>
-              <a:t>LIVE MVP</a:t>
-            </a:r>
-          </a:p>
-        </p:txBody>
-      </p:sp>
-      <p:sp>
-        <p:nvSpPr>
-          <p:cNvPr id="16" name="TextBox 15"/>
-          <p:cNvSpPr txBox="1"/>
-          <p:nvPr/>
-        </p:nvSpPr>
-        <p:spPr>
-          <a:xfrm>
-            <a:off x="2331720" y="4718304"/>
-            <a:ext cx="8869680" cy="292608"/>
-          </a:xfrm>
-          <a:prstGeom prst="rect">
-            <a:avLst/>
-          </a:prstGeom>
-          <a:noFill/>
-        </p:spPr>
-        <p:txBody>
-          <a:bodyPr wrap="square" lIns="27432" rIns="27432" tIns="27432" bIns="27432" anchor="t">
-            <a:spAutoFit/>
-          </a:bodyPr>
-          <a:lstStyle/>
-          <a:p>
-            <a:pPr algn="l">
-              <a:spcAft>
-                <a:spcPts val="500"/>
-              </a:spcAft>
-              <a:defRPr sz="1500" b="0">
-                <a:solidFill>
-                  <a:srgbClr val="24563E"/>
-                </a:solidFill>
-                <a:latin typeface="Aptos"/>
-              </a:defRPr>
-            </a:pPr>
-            <a:r>
-              <a:t>https://proofforge-cyber.onrender.com</a:t>
-            </a:r>
-          </a:p>
-        </p:txBody>
-      </p:sp>
-      <p:sp>
-        <p:nvSpPr>
-          <p:cNvPr id="17" name="TextBox 16"/>
-          <p:cNvSpPr txBox="1"/>
-          <p:nvPr/>
-        </p:nvSpPr>
-        <p:spPr>
-          <a:xfrm>
-            <a:off x="914400" y="5166360"/>
-            <a:ext cx="1371600" cy="228600"/>
-          </a:xfrm>
-          <a:prstGeom prst="rect">
-            <a:avLst/>
-          </a:prstGeom>
-          <a:noFill/>
-        </p:spPr>
-        <p:txBody>
-          <a:bodyPr wrap="square" lIns="27432" rIns="27432" tIns="27432" bIns="27432" anchor="t">
-            <a:spAutoFit/>
-          </a:bodyPr>
-          <a:lstStyle/>
-          <a:p>
-            <a:pPr algn="l">
-              <a:spcAft>
-                <a:spcPts val="500"/>
-              </a:spcAft>
-              <a:defRPr sz="1300" b="1">
-                <a:solidFill>
-                  <a:srgbClr val="24563E"/>
-                </a:solidFill>
-                <a:latin typeface="Aptos"/>
-              </a:defRPr>
-            </a:pPr>
-            <a:r>
-              <a:t>REPOSITORY</a:t>
-            </a:r>
-          </a:p>
-        </p:txBody>
-      </p:sp>
-      <p:sp>
-        <p:nvSpPr>
-          <p:cNvPr id="18" name="TextBox 17"/>
-          <p:cNvSpPr txBox="1"/>
-          <p:nvPr/>
-        </p:nvSpPr>
-        <p:spPr>
-          <a:xfrm>
-            <a:off x="2331720" y="5129784"/>
-            <a:ext cx="8869680" cy="292608"/>
-          </a:xfrm>
-          <a:prstGeom prst="rect">
-            <a:avLst/>
-          </a:prstGeom>
-          <a:noFill/>
-        </p:spPr>
-        <p:txBody>
-          <a:bodyPr wrap="square" lIns="27432" rIns="27432" tIns="27432" bIns="27432" anchor="t">
-            <a:spAutoFit/>
-          </a:bodyPr>
-          <a:lstStyle/>
-          <a:p>
-            <a:pPr algn="l">
-              <a:spcAft>
-                <a:spcPts val="500"/>
-              </a:spcAft>
-              <a:defRPr sz="1500" b="0">
-                <a:solidFill>
-                  <a:srgbClr val="25332C"/>
-                </a:solidFill>
-                <a:latin typeface="Aptos"/>
-              </a:defRPr>
-            </a:pPr>
-            <a:r>
-              <a:t>github.com/yogesh-37911/HM26-C3B5-Phase2</a:t>
-            </a:r>
-          </a:p>
-        </p:txBody>
-      </p:sp>
-      <p:sp>
-        <p:nvSpPr>
-          <p:cNvPr id="19" name="TextBox 18"/>
-          <p:cNvSpPr txBox="1"/>
-          <p:nvPr/>
-        </p:nvSpPr>
-        <p:spPr>
-          <a:xfrm>
-            <a:off x="914400" y="5532120"/>
-            <a:ext cx="9875520" cy="228600"/>
-          </a:xfrm>
-          <a:prstGeom prst="rect">
-            <a:avLst/>
-          </a:prstGeom>
-          <a:noFill/>
-        </p:spPr>
-        <p:txBody>
-          <a:bodyPr wrap="square" lIns="27432" rIns="27432" tIns="27432" bIns="27432" anchor="t">
-            <a:spAutoFit/>
-          </a:bodyPr>
-          <a:lstStyle/>
-          <a:p>
-            <a:pPr algn="l">
-              <a:spcAft>
-                <a:spcPts val="500"/>
-              </a:spcAft>
-              <a:defRPr sz="1400" b="0">
-                <a:solidFill>
-                  <a:srgbClr val="65756C"/>
-                </a:solidFill>
-                <a:latin typeface="Aptos"/>
-              </a:defRPr>
-            </a:pPr>
-            <a:r>
-              <a:t>Team members / colleges: [add names]</a:t>
-            </a:r>
-          </a:p>
-        </p:txBody>
-      </p:sp>
+            <a:endParaRPr/>
+          </a:p>
+        </p:txBody>
+      </p:sp>
+      <p:grpSp>
+        <p:nvGrpSpPr>
+          <p:cNvPr id="20" name="Group 19">
+            <a:extLst>
+              <a:ext uri="{FF2B5EF4-FFF2-40B4-BE49-F238E27FC236}">
+                <a16:creationId xmlns:a16="http://schemas.microsoft.com/office/drawing/2014/main" id="{9BC40C8E-777F-C18E-3740-D743C7EEA776}"/>
+              </a:ext>
+            </a:extLst>
+          </p:cNvPr>
+          <p:cNvGrpSpPr/>
+          <p:nvPr/>
+        </p:nvGrpSpPr>
+        <p:grpSpPr>
+          <a:xfrm>
+            <a:off x="960120" y="4809744"/>
+            <a:ext cx="10287000" cy="704088"/>
+            <a:chOff x="914400" y="4718304"/>
+            <a:chExt cx="10287000" cy="704088"/>
+          </a:xfrm>
+        </p:grpSpPr>
+        <p:sp>
+          <p:nvSpPr>
+            <p:cNvPr id="15" name="TextBox 14"/>
+            <p:cNvSpPr txBox="1"/>
+            <p:nvPr/>
+          </p:nvSpPr>
+          <p:spPr>
+            <a:xfrm>
+              <a:off x="914400" y="4754880"/>
+              <a:ext cx="1371600" cy="228600"/>
+            </a:xfrm>
+            <a:prstGeom prst="rect">
+              <a:avLst/>
+            </a:prstGeom>
+            <a:noFill/>
+          </p:spPr>
+          <p:txBody>
+            <a:bodyPr wrap="square" lIns="27432" tIns="27432" rIns="27432" bIns="27432" anchor="t">
+              <a:spAutoFit/>
+            </a:bodyPr>
+            <a:lstStyle/>
+            <a:p>
+              <a:pPr algn="l">
+                <a:spcAft>
+                  <a:spcPts val="500"/>
+                </a:spcAft>
+                <a:defRPr sz="1300" b="1">
+                  <a:solidFill>
+                    <a:srgbClr val="24563E"/>
+                  </a:solidFill>
+                  <a:latin typeface="Aptos"/>
+                </a:defRPr>
+              </a:pPr>
+              <a:r>
+                <a:rPr dirty="0"/>
+                <a:t>LIVE MVP</a:t>
+              </a:r>
+            </a:p>
+          </p:txBody>
+        </p:sp>
+        <p:sp>
+          <p:nvSpPr>
+            <p:cNvPr id="16" name="TextBox 15"/>
+            <p:cNvSpPr txBox="1"/>
+            <p:nvPr/>
+          </p:nvSpPr>
+          <p:spPr>
+            <a:xfrm>
+              <a:off x="2331720" y="4718304"/>
+              <a:ext cx="8869680" cy="292608"/>
+            </a:xfrm>
+            <a:prstGeom prst="rect">
+              <a:avLst/>
+            </a:prstGeom>
+            <a:noFill/>
+          </p:spPr>
+          <p:txBody>
+            <a:bodyPr wrap="square" lIns="27432" tIns="27432" rIns="27432" bIns="27432" anchor="t">
+              <a:spAutoFit/>
+            </a:bodyPr>
+            <a:lstStyle/>
+            <a:p>
+              <a:pPr algn="l">
+                <a:spcAft>
+                  <a:spcPts val="500"/>
+                </a:spcAft>
+                <a:defRPr sz="1500" b="0">
+                  <a:solidFill>
+                    <a:srgbClr val="24563E"/>
+                  </a:solidFill>
+                  <a:latin typeface="Aptos"/>
+                </a:defRPr>
+              </a:pPr>
+              <a:r>
+                <a:rPr dirty="0"/>
+                <a:t>https://proofforge-cyber.onrender.com</a:t>
+              </a:r>
+            </a:p>
+          </p:txBody>
+        </p:sp>
+        <p:sp>
+          <p:nvSpPr>
+            <p:cNvPr id="17" name="TextBox 16"/>
+            <p:cNvSpPr txBox="1"/>
+            <p:nvPr/>
+          </p:nvSpPr>
+          <p:spPr>
+            <a:xfrm>
+              <a:off x="914400" y="5166360"/>
+              <a:ext cx="1371600" cy="228600"/>
+            </a:xfrm>
+            <a:prstGeom prst="rect">
+              <a:avLst/>
+            </a:prstGeom>
+            <a:noFill/>
+          </p:spPr>
+          <p:txBody>
+            <a:bodyPr wrap="square" lIns="27432" tIns="27432" rIns="27432" bIns="27432" anchor="t">
+              <a:spAutoFit/>
+            </a:bodyPr>
+            <a:lstStyle/>
+            <a:p>
+              <a:pPr algn="l">
+                <a:spcAft>
+                  <a:spcPts val="500"/>
+                </a:spcAft>
+                <a:defRPr sz="1300" b="1">
+                  <a:solidFill>
+                    <a:srgbClr val="24563E"/>
+                  </a:solidFill>
+                  <a:latin typeface="Aptos"/>
+                </a:defRPr>
+              </a:pPr>
+              <a:r>
+                <a:rPr dirty="0"/>
+                <a:t>REPOSITORY</a:t>
+              </a:r>
+            </a:p>
+          </p:txBody>
+        </p:sp>
+        <p:sp>
+          <p:nvSpPr>
+            <p:cNvPr id="18" name="TextBox 17"/>
+            <p:cNvSpPr txBox="1"/>
+            <p:nvPr/>
+          </p:nvSpPr>
+          <p:spPr>
+            <a:xfrm>
+              <a:off x="2331720" y="5129784"/>
+              <a:ext cx="8869680" cy="292608"/>
+            </a:xfrm>
+            <a:prstGeom prst="rect">
+              <a:avLst/>
+            </a:prstGeom>
+            <a:noFill/>
+          </p:spPr>
+          <p:txBody>
+            <a:bodyPr wrap="square" lIns="27432" tIns="27432" rIns="27432" bIns="27432" anchor="t">
+              <a:spAutoFit/>
+            </a:bodyPr>
+            <a:lstStyle/>
+            <a:p>
+              <a:pPr algn="l">
+                <a:spcAft>
+                  <a:spcPts val="500"/>
+                </a:spcAft>
+                <a:defRPr sz="1500" b="0">
+                  <a:solidFill>
+                    <a:srgbClr val="25332C"/>
+                  </a:solidFill>
+                  <a:latin typeface="Aptos"/>
+                </a:defRPr>
+              </a:pPr>
+              <a:r>
+                <a:rPr dirty="0"/>
+                <a:t>github.com/yogesh-37911/HM26-C3B5-Phase2</a:t>
+              </a:r>
+            </a:p>
+          </p:txBody>
+        </p:sp>
+      </p:grpSp>
     </p:spTree>
   </p:cSld>
   <p:clrMapOvr>
@@ -4415,7 +4611,7 @@
 </file>
 
 <file path=ppt/slides/slide2.xml><?xml version="1.0" encoding="utf-8"?>
-<p:sld xmlns:a="http://schemas.openxmlformats.org/drawingml/2006/main" xmlns:p="http://schemas.openxmlformats.org/presentationml/2006/main" xmlns:r="http://schemas.openxmlformats.org/officeDocument/2006/relationships">
+<p:sld xmlns:a="http://schemas.openxmlformats.org/drawingml/2006/main" xmlns:r="http://schemas.openxmlformats.org/officeDocument/2006/relationships" xmlns:p="http://schemas.openxmlformats.org/presentationml/2006/main">
   <p:cSld>
     <p:bg>
       <p:bgPr>
@@ -4431,7 +4627,14 @@
         <p:cNvGrpSpPr/>
         <p:nvPr/>
       </p:nvGrpSpPr>
-      <p:grpSpPr/>
+      <p:grpSpPr>
+        <a:xfrm>
+          <a:off x="0" y="0"/>
+          <a:ext cx="0" cy="0"/>
+          <a:chOff x="0" y="0"/>
+          <a:chExt cx="0" cy="0"/>
+        </a:xfrm>
+      </p:grpSpPr>
       <p:sp>
         <p:nvSpPr>
           <p:cNvPr id="2" name="Rectangle 1"/>
@@ -4474,6 +4677,7 @@
           <a:lstStyle/>
           <a:p>
             <a:pPr algn="ctr"/>
+            <a:endParaRPr/>
           </a:p>
         </p:txBody>
       </p:sp>
@@ -4494,7 +4698,7 @@
           <a:noFill/>
         </p:spPr>
         <p:txBody>
-          <a:bodyPr wrap="square" lIns="27432" rIns="27432" tIns="27432" bIns="27432" anchor="t">
+          <a:bodyPr wrap="square" lIns="27432" tIns="27432" rIns="27432" bIns="27432" anchor="t">
             <a:spAutoFit/>
           </a:bodyPr>
           <a:lstStyle/>
@@ -4533,7 +4737,7 @@
           <a:noFill/>
         </p:spPr>
         <p:txBody>
-          <a:bodyPr wrap="square" lIns="27432" rIns="27432" tIns="27432" bIns="27432" anchor="t">
+          <a:bodyPr wrap="square" lIns="27432" tIns="27432" rIns="27432" bIns="27432" anchor="t">
             <a:spAutoFit/>
           </a:bodyPr>
           <a:lstStyle/>
@@ -4572,7 +4776,7 @@
           <a:noFill/>
         </p:spPr>
         <p:txBody>
-          <a:bodyPr wrap="square" lIns="27432" rIns="27432" tIns="27432" bIns="27432" anchor="t">
+          <a:bodyPr wrap="square" lIns="27432" tIns="27432" rIns="27432" bIns="27432" anchor="t">
             <a:spAutoFit/>
           </a:bodyPr>
           <a:lstStyle/>
@@ -4636,6 +4840,7 @@
           <a:lstStyle/>
           <a:p>
             <a:pPr algn="ctr"/>
+            <a:endParaRPr/>
           </a:p>
         </p:txBody>
       </p:sp>
@@ -4681,6 +4886,7 @@
           <a:lstStyle/>
           <a:p>
             <a:pPr algn="ctr"/>
+            <a:endParaRPr/>
           </a:p>
         </p:txBody>
       </p:sp>
@@ -4701,7 +4907,7 @@
           <a:noFill/>
         </p:spPr>
         <p:txBody>
-          <a:bodyPr wrap="square" lIns="27432" rIns="27432" tIns="27432" bIns="27432" anchor="t">
+          <a:bodyPr wrap="square" lIns="27432" tIns="27432" rIns="27432" bIns="27432" anchor="t">
             <a:spAutoFit/>
           </a:bodyPr>
           <a:lstStyle/>
@@ -4740,7 +4946,7 @@
           <a:noFill/>
         </p:spPr>
         <p:txBody>
-          <a:bodyPr wrap="square" lIns="27432" rIns="27432" tIns="27432" bIns="27432" anchor="t">
+          <a:bodyPr wrap="square" lIns="27432" tIns="27432" rIns="27432" bIns="27432" anchor="t">
             <a:spAutoFit/>
           </a:bodyPr>
           <a:lstStyle/>
@@ -4779,7 +4985,7 @@
           <a:noFill/>
         </p:spPr>
         <p:txBody>
-          <a:bodyPr wrap="square" lIns="27432" rIns="27432" tIns="27432" bIns="27432" anchor="t">
+          <a:bodyPr wrap="square" lIns="27432" tIns="27432" rIns="27432" bIns="27432" anchor="t">
             <a:spAutoFit/>
           </a:bodyPr>
           <a:lstStyle/>
@@ -4845,6 +5051,7 @@
           <a:lstStyle/>
           <a:p>
             <a:pPr algn="ctr"/>
+            <a:endParaRPr/>
           </a:p>
         </p:txBody>
       </p:sp>
@@ -4865,7 +5072,7 @@
           <a:noFill/>
         </p:spPr>
         <p:txBody>
-          <a:bodyPr wrap="square" lIns="27432" rIns="27432" tIns="27432" bIns="27432" anchor="t">
+          <a:bodyPr wrap="square" lIns="27432" tIns="27432" rIns="27432" bIns="27432" anchor="t">
             <a:spAutoFit/>
           </a:bodyPr>
           <a:lstStyle/>
@@ -4904,7 +5111,7 @@
           <a:noFill/>
         </p:spPr>
         <p:txBody>
-          <a:bodyPr wrap="square" lIns="27432" rIns="27432" tIns="27432" bIns="27432" anchor="t">
+          <a:bodyPr wrap="square" lIns="27432" tIns="27432" rIns="27432" bIns="27432" anchor="t">
             <a:spAutoFit/>
           </a:bodyPr>
           <a:lstStyle/>
@@ -4943,7 +5150,7 @@
           <a:noFill/>
         </p:spPr>
         <p:txBody>
-          <a:bodyPr wrap="square" lIns="27432" rIns="27432" tIns="27432" bIns="27432" anchor="t">
+          <a:bodyPr wrap="square" lIns="27432" tIns="27432" rIns="27432" bIns="27432" anchor="t">
             <a:spAutoFit/>
           </a:bodyPr>
           <a:lstStyle/>
@@ -4974,7 +5181,7 @@
 </file>
 
 <file path=ppt/slides/slide3.xml><?xml version="1.0" encoding="utf-8"?>
-<p:sld xmlns:a="http://schemas.openxmlformats.org/drawingml/2006/main" xmlns:p="http://schemas.openxmlformats.org/presentationml/2006/main" xmlns:r="http://schemas.openxmlformats.org/officeDocument/2006/relationships">
+<p:sld xmlns:a="http://schemas.openxmlformats.org/drawingml/2006/main" xmlns:r="http://schemas.openxmlformats.org/officeDocument/2006/relationships" xmlns:p="http://schemas.openxmlformats.org/presentationml/2006/main">
   <p:cSld>
     <p:bg>
       <p:bgPr>
@@ -4990,7 +5197,14 @@
         <p:cNvGrpSpPr/>
         <p:nvPr/>
       </p:nvGrpSpPr>
-      <p:grpSpPr/>
+      <p:grpSpPr>
+        <a:xfrm>
+          <a:off x="0" y="0"/>
+          <a:ext cx="0" cy="0"/>
+          <a:chOff x="0" y="0"/>
+          <a:chExt cx="0" cy="0"/>
+        </a:xfrm>
+      </p:grpSpPr>
       <p:sp>
         <p:nvSpPr>
           <p:cNvPr id="2" name="Rectangle 1"/>
@@ -5033,6 +5247,7 @@
           <a:lstStyle/>
           <a:p>
             <a:pPr algn="ctr"/>
+            <a:endParaRPr/>
           </a:p>
         </p:txBody>
       </p:sp>
@@ -5053,7 +5268,7 @@
           <a:noFill/>
         </p:spPr>
         <p:txBody>
-          <a:bodyPr wrap="square" lIns="27432" rIns="27432" tIns="27432" bIns="27432" anchor="t">
+          <a:bodyPr wrap="square" lIns="27432" tIns="27432" rIns="27432" bIns="27432" anchor="t">
             <a:spAutoFit/>
           </a:bodyPr>
           <a:lstStyle/>
@@ -5092,7 +5307,7 @@
           <a:noFill/>
         </p:spPr>
         <p:txBody>
-          <a:bodyPr wrap="square" lIns="27432" rIns="27432" tIns="27432" bIns="27432" anchor="t">
+          <a:bodyPr wrap="square" lIns="27432" tIns="27432" rIns="27432" bIns="27432" anchor="t">
             <a:spAutoFit/>
           </a:bodyPr>
           <a:lstStyle/>
@@ -5131,7 +5346,7 @@
           <a:noFill/>
         </p:spPr>
         <p:txBody>
-          <a:bodyPr wrap="square" lIns="27432" rIns="27432" tIns="27432" bIns="27432" anchor="t">
+          <a:bodyPr wrap="square" lIns="27432" tIns="27432" rIns="27432" bIns="27432" anchor="t">
             <a:spAutoFit/>
           </a:bodyPr>
           <a:lstStyle/>
@@ -5195,6 +5410,7 @@
           <a:lstStyle/>
           <a:p>
             <a:pPr algn="ctr"/>
+            <a:endParaRPr/>
           </a:p>
         </p:txBody>
       </p:sp>
@@ -5240,6 +5456,7 @@
           <a:lstStyle/>
           <a:p>
             <a:pPr algn="ctr"/>
+            <a:endParaRPr/>
           </a:p>
         </p:txBody>
       </p:sp>
@@ -5260,7 +5477,7 @@
           <a:noFill/>
         </p:spPr>
         <p:txBody>
-          <a:bodyPr wrap="square" lIns="27432" rIns="27432" tIns="27432" bIns="27432" anchor="t">
+          <a:bodyPr wrap="square" lIns="27432" tIns="27432" rIns="27432" bIns="27432" anchor="t">
             <a:spAutoFit/>
           </a:bodyPr>
           <a:lstStyle/>
@@ -5299,7 +5516,7 @@
           <a:noFill/>
         </p:spPr>
         <p:txBody>
-          <a:bodyPr wrap="square" lIns="27432" rIns="27432" tIns="27432" bIns="27432" anchor="t">
+          <a:bodyPr wrap="square" lIns="27432" tIns="27432" rIns="27432" bIns="27432" anchor="t">
             <a:spAutoFit/>
           </a:bodyPr>
           <a:lstStyle/>
@@ -5365,6 +5582,7 @@
           <a:lstStyle/>
           <a:p>
             <a:pPr algn="ctr"/>
+            <a:endParaRPr/>
           </a:p>
         </p:txBody>
       </p:sp>
@@ -5385,7 +5603,7 @@
           <a:noFill/>
         </p:spPr>
         <p:txBody>
-          <a:bodyPr wrap="square" lIns="27432" rIns="27432" tIns="27432" bIns="27432" anchor="t">
+          <a:bodyPr wrap="square" lIns="27432" tIns="27432" rIns="27432" bIns="27432" anchor="t">
             <a:spAutoFit/>
           </a:bodyPr>
           <a:lstStyle/>
@@ -5424,7 +5642,7 @@
           <a:noFill/>
         </p:spPr>
         <p:txBody>
-          <a:bodyPr wrap="square" lIns="27432" rIns="27432" tIns="27432" bIns="27432" anchor="t">
+          <a:bodyPr wrap="square" lIns="27432" tIns="27432" rIns="27432" bIns="27432" anchor="t">
             <a:spAutoFit/>
           </a:bodyPr>
           <a:lstStyle/>
@@ -5490,6 +5708,7 @@
           <a:lstStyle/>
           <a:p>
             <a:pPr algn="ctr"/>
+            <a:endParaRPr/>
           </a:p>
         </p:txBody>
       </p:sp>
@@ -5510,7 +5729,7 @@
           <a:noFill/>
         </p:spPr>
         <p:txBody>
-          <a:bodyPr wrap="square" lIns="27432" rIns="27432" tIns="27432" bIns="27432" anchor="t">
+          <a:bodyPr wrap="square" lIns="27432" tIns="27432" rIns="27432" bIns="27432" anchor="t">
             <a:spAutoFit/>
           </a:bodyPr>
           <a:lstStyle/>
@@ -5549,7 +5768,7 @@
           <a:noFill/>
         </p:spPr>
         <p:txBody>
-          <a:bodyPr wrap="square" lIns="27432" rIns="27432" tIns="27432" bIns="27432" anchor="t">
+          <a:bodyPr wrap="square" lIns="27432" tIns="27432" rIns="27432" bIns="27432" anchor="t">
             <a:spAutoFit/>
           </a:bodyPr>
           <a:lstStyle/>
@@ -5615,6 +5834,7 @@
           <a:lstStyle/>
           <a:p>
             <a:pPr algn="ctr"/>
+            <a:endParaRPr/>
           </a:p>
         </p:txBody>
       </p:sp>
@@ -5635,7 +5855,7 @@
           <a:noFill/>
         </p:spPr>
         <p:txBody>
-          <a:bodyPr wrap="square" lIns="27432" rIns="27432" tIns="27432" bIns="27432" anchor="t">
+          <a:bodyPr wrap="square" lIns="27432" tIns="27432" rIns="27432" bIns="27432" anchor="t">
             <a:spAutoFit/>
           </a:bodyPr>
           <a:lstStyle/>
@@ -5674,7 +5894,7 @@
           <a:noFill/>
         </p:spPr>
         <p:txBody>
-          <a:bodyPr wrap="square" lIns="27432" rIns="27432" tIns="27432" bIns="27432" anchor="t">
+          <a:bodyPr wrap="square" lIns="27432" tIns="27432" rIns="27432" bIns="27432" anchor="t">
             <a:spAutoFit/>
           </a:bodyPr>
           <a:lstStyle/>
@@ -5705,7 +5925,7 @@
 </file>
 
 <file path=ppt/slides/slide4.xml><?xml version="1.0" encoding="utf-8"?>
-<p:sld xmlns:a="http://schemas.openxmlformats.org/drawingml/2006/main" xmlns:p="http://schemas.openxmlformats.org/presentationml/2006/main" xmlns:r="http://schemas.openxmlformats.org/officeDocument/2006/relationships">
+<p:sld xmlns:a="http://schemas.openxmlformats.org/drawingml/2006/main" xmlns:r="http://schemas.openxmlformats.org/officeDocument/2006/relationships" xmlns:p="http://schemas.openxmlformats.org/presentationml/2006/main">
   <p:cSld>
     <p:bg>
       <p:bgPr>
@@ -5721,7 +5941,14 @@
         <p:cNvGrpSpPr/>
         <p:nvPr/>
       </p:nvGrpSpPr>
-      <p:grpSpPr/>
+      <p:grpSpPr>
+        <a:xfrm>
+          <a:off x="0" y="0"/>
+          <a:ext cx="0" cy="0"/>
+          <a:chOff x="0" y="0"/>
+          <a:chExt cx="0" cy="0"/>
+        </a:xfrm>
+      </p:grpSpPr>
       <p:sp>
         <p:nvSpPr>
           <p:cNvPr id="2" name="Rectangle 1"/>
@@ -5764,6 +5991,7 @@
           <a:lstStyle/>
           <a:p>
             <a:pPr algn="ctr"/>
+            <a:endParaRPr/>
           </a:p>
         </p:txBody>
       </p:sp>
@@ -5784,7 +6012,7 @@
           <a:noFill/>
         </p:spPr>
         <p:txBody>
-          <a:bodyPr wrap="square" lIns="27432" rIns="27432" tIns="27432" bIns="27432" anchor="t">
+          <a:bodyPr wrap="square" lIns="27432" tIns="27432" rIns="27432" bIns="27432" anchor="t">
             <a:spAutoFit/>
           </a:bodyPr>
           <a:lstStyle/>
@@ -5823,7 +6051,7 @@
           <a:noFill/>
         </p:spPr>
         <p:txBody>
-          <a:bodyPr wrap="square" lIns="27432" rIns="27432" tIns="27432" bIns="27432" anchor="t">
+          <a:bodyPr wrap="square" lIns="27432" tIns="27432" rIns="27432" bIns="27432" anchor="t">
             <a:spAutoFit/>
           </a:bodyPr>
           <a:lstStyle/>
@@ -5862,7 +6090,7 @@
           <a:noFill/>
         </p:spPr>
         <p:txBody>
-          <a:bodyPr wrap="square" lIns="27432" rIns="27432" tIns="27432" bIns="27432" anchor="t">
+          <a:bodyPr wrap="square" lIns="27432" tIns="27432" rIns="27432" bIns="27432" anchor="t">
             <a:spAutoFit/>
           </a:bodyPr>
           <a:lstStyle/>
@@ -5926,6 +6154,7 @@
           <a:lstStyle/>
           <a:p>
             <a:pPr algn="ctr"/>
+            <a:endParaRPr/>
           </a:p>
         </p:txBody>
       </p:sp>
@@ -5971,6 +6200,7 @@
           <a:lstStyle/>
           <a:p>
             <a:pPr algn="ctr"/>
+            <a:endParaRPr/>
           </a:p>
         </p:txBody>
       </p:sp>
@@ -5991,7 +6221,7 @@
           <a:noFill/>
         </p:spPr>
         <p:txBody>
-          <a:bodyPr wrap="square" lIns="27432" rIns="27432" tIns="27432" bIns="27432" anchor="t">
+          <a:bodyPr wrap="square" lIns="27432" tIns="27432" rIns="27432" bIns="27432" anchor="t">
             <a:spAutoFit/>
           </a:bodyPr>
           <a:lstStyle/>
@@ -6030,7 +6260,7 @@
           <a:noFill/>
         </p:spPr>
         <p:txBody>
-          <a:bodyPr wrap="square" lIns="27432" rIns="27432" tIns="27432" bIns="27432" anchor="t">
+          <a:bodyPr wrap="square" lIns="27432" tIns="27432" rIns="27432" bIns="27432" anchor="t">
             <a:spAutoFit/>
           </a:bodyPr>
           <a:lstStyle/>
@@ -6094,6 +6324,7 @@
           <a:lstStyle/>
           <a:p>
             <a:pPr algn="ctr"/>
+            <a:endParaRPr/>
           </a:p>
         </p:txBody>
       </p:sp>
@@ -6114,7 +6345,7 @@
           <a:noFill/>
         </p:spPr>
         <p:txBody>
-          <a:bodyPr wrap="square" lIns="27432" rIns="27432" tIns="27432" bIns="27432" anchor="t">
+          <a:bodyPr wrap="square" lIns="27432" tIns="27432" rIns="27432" bIns="27432" anchor="t">
             <a:spAutoFit/>
           </a:bodyPr>
           <a:lstStyle/>
@@ -6153,7 +6384,7 @@
           <a:noFill/>
         </p:spPr>
         <p:txBody>
-          <a:bodyPr wrap="square" lIns="27432" rIns="27432" tIns="27432" bIns="27432" anchor="t">
+          <a:bodyPr wrap="square" lIns="27432" tIns="27432" rIns="27432" bIns="27432" anchor="t">
             <a:spAutoFit/>
           </a:bodyPr>
           <a:lstStyle/>
@@ -6217,6 +6448,7 @@
           <a:lstStyle/>
           <a:p>
             <a:pPr algn="ctr"/>
+            <a:endParaRPr/>
           </a:p>
         </p:txBody>
       </p:sp>
@@ -6237,7 +6469,7 @@
           <a:noFill/>
         </p:spPr>
         <p:txBody>
-          <a:bodyPr wrap="square" lIns="27432" rIns="27432" tIns="27432" bIns="27432" anchor="t">
+          <a:bodyPr wrap="square" lIns="27432" tIns="27432" rIns="27432" bIns="27432" anchor="t">
             <a:spAutoFit/>
           </a:bodyPr>
           <a:lstStyle/>
@@ -6276,7 +6508,7 @@
           <a:noFill/>
         </p:spPr>
         <p:txBody>
-          <a:bodyPr wrap="square" lIns="27432" rIns="27432" tIns="27432" bIns="27432" anchor="t">
+          <a:bodyPr wrap="square" lIns="27432" tIns="27432" rIns="27432" bIns="27432" anchor="t">
             <a:spAutoFit/>
           </a:bodyPr>
           <a:lstStyle/>
@@ -6340,6 +6572,7 @@
           <a:lstStyle/>
           <a:p>
             <a:pPr algn="ctr"/>
+            <a:endParaRPr/>
           </a:p>
         </p:txBody>
       </p:sp>
@@ -6360,7 +6593,7 @@
           <a:noFill/>
         </p:spPr>
         <p:txBody>
-          <a:bodyPr wrap="square" lIns="27432" rIns="27432" tIns="27432" bIns="27432" anchor="t">
+          <a:bodyPr wrap="square" lIns="27432" tIns="27432" rIns="27432" bIns="27432" anchor="t">
             <a:spAutoFit/>
           </a:bodyPr>
           <a:lstStyle/>
@@ -6399,7 +6632,7 @@
           <a:noFill/>
         </p:spPr>
         <p:txBody>
-          <a:bodyPr wrap="square" lIns="27432" rIns="27432" tIns="27432" bIns="27432" anchor="t">
+          <a:bodyPr wrap="square" lIns="27432" tIns="27432" rIns="27432" bIns="27432" anchor="t">
             <a:spAutoFit/>
           </a:bodyPr>
           <a:lstStyle/>
@@ -6463,6 +6696,7 @@
           <a:lstStyle/>
           <a:p>
             <a:pPr algn="ctr"/>
+            <a:endParaRPr/>
           </a:p>
         </p:txBody>
       </p:sp>
@@ -6483,7 +6717,7 @@
           <a:noFill/>
         </p:spPr>
         <p:txBody>
-          <a:bodyPr wrap="square" lIns="27432" rIns="27432" tIns="27432" bIns="27432" anchor="t">
+          <a:bodyPr wrap="square" lIns="27432" tIns="27432" rIns="27432" bIns="27432" anchor="t">
             <a:spAutoFit/>
           </a:bodyPr>
           <a:lstStyle/>
@@ -6522,7 +6756,7 @@
           <a:noFill/>
         </p:spPr>
         <p:txBody>
-          <a:bodyPr wrap="square" lIns="27432" rIns="27432" tIns="27432" bIns="27432" anchor="t">
+          <a:bodyPr wrap="square" lIns="27432" tIns="27432" rIns="27432" bIns="27432" anchor="t">
             <a:spAutoFit/>
           </a:bodyPr>
           <a:lstStyle/>
@@ -6586,6 +6820,7 @@
           <a:lstStyle/>
           <a:p>
             <a:pPr algn="ctr"/>
+            <a:endParaRPr/>
           </a:p>
         </p:txBody>
       </p:sp>
@@ -6606,7 +6841,7 @@
           <a:noFill/>
         </p:spPr>
         <p:txBody>
-          <a:bodyPr wrap="square" lIns="27432" rIns="27432" tIns="27432" bIns="27432" anchor="t">
+          <a:bodyPr wrap="square" lIns="27432" tIns="27432" rIns="27432" bIns="27432" anchor="t">
             <a:spAutoFit/>
           </a:bodyPr>
           <a:lstStyle/>
@@ -6645,7 +6880,7 @@
           <a:noFill/>
         </p:spPr>
         <p:txBody>
-          <a:bodyPr wrap="square" lIns="27432" rIns="27432" tIns="27432" bIns="27432" anchor="t">
+          <a:bodyPr wrap="square" lIns="27432" tIns="27432" rIns="27432" bIns="27432" anchor="t">
             <a:spAutoFit/>
           </a:bodyPr>
           <a:lstStyle/>
@@ -6711,6 +6946,7 @@
           <a:lstStyle/>
           <a:p>
             <a:pPr algn="ctr"/>
+            <a:endParaRPr/>
           </a:p>
         </p:txBody>
       </p:sp>
@@ -6731,7 +6967,7 @@
           <a:noFill/>
         </p:spPr>
         <p:txBody>
-          <a:bodyPr wrap="square" lIns="27432" rIns="27432" tIns="27432" bIns="27432" anchor="t">
+          <a:bodyPr wrap="square" lIns="27432" tIns="27432" rIns="27432" bIns="27432" anchor="t">
             <a:spAutoFit/>
           </a:bodyPr>
           <a:lstStyle/>
@@ -6770,7 +7006,7 @@
           <a:noFill/>
         </p:spPr>
         <p:txBody>
-          <a:bodyPr wrap="square" lIns="27432" rIns="27432" tIns="27432" bIns="27432" anchor="t">
+          <a:bodyPr wrap="square" lIns="27432" tIns="27432" rIns="27432" bIns="27432" anchor="t">
             <a:spAutoFit/>
           </a:bodyPr>
           <a:lstStyle/>
@@ -6801,7 +7037,7 @@
 </file>
 
 <file path=ppt/slides/slide5.xml><?xml version="1.0" encoding="utf-8"?>
-<p:sld xmlns:a="http://schemas.openxmlformats.org/drawingml/2006/main" xmlns:p="http://schemas.openxmlformats.org/presentationml/2006/main" xmlns:r="http://schemas.openxmlformats.org/officeDocument/2006/relationships">
+<p:sld xmlns:a="http://schemas.openxmlformats.org/drawingml/2006/main" xmlns:r="http://schemas.openxmlformats.org/officeDocument/2006/relationships" xmlns:p="http://schemas.openxmlformats.org/presentationml/2006/main">
   <p:cSld>
     <p:bg>
       <p:bgPr>
@@ -6817,7 +7053,14 @@
         <p:cNvGrpSpPr/>
         <p:nvPr/>
       </p:nvGrpSpPr>
-      <p:grpSpPr/>
+      <p:grpSpPr>
+        <a:xfrm>
+          <a:off x="0" y="0"/>
+          <a:ext cx="0" cy="0"/>
+          <a:chOff x="0" y="0"/>
+          <a:chExt cx="0" cy="0"/>
+        </a:xfrm>
+      </p:grpSpPr>
       <p:sp>
         <p:nvSpPr>
           <p:cNvPr id="2" name="Rectangle 1"/>
@@ -6860,6 +7103,7 @@
           <a:lstStyle/>
           <a:p>
             <a:pPr algn="ctr"/>
+            <a:endParaRPr/>
           </a:p>
         </p:txBody>
       </p:sp>
@@ -6880,7 +7124,7 @@
           <a:noFill/>
         </p:spPr>
         <p:txBody>
-          <a:bodyPr wrap="square" lIns="27432" rIns="27432" tIns="27432" bIns="27432" anchor="t">
+          <a:bodyPr wrap="square" lIns="27432" tIns="27432" rIns="27432" bIns="27432" anchor="t">
             <a:spAutoFit/>
           </a:bodyPr>
           <a:lstStyle/>
@@ -6919,7 +7163,7 @@
           <a:noFill/>
         </p:spPr>
         <p:txBody>
-          <a:bodyPr wrap="square" lIns="27432" rIns="27432" tIns="27432" bIns="27432" anchor="t">
+          <a:bodyPr wrap="square" lIns="27432" tIns="27432" rIns="27432" bIns="27432" anchor="t">
             <a:spAutoFit/>
           </a:bodyPr>
           <a:lstStyle/>
@@ -6958,7 +7202,7 @@
           <a:noFill/>
         </p:spPr>
         <p:txBody>
-          <a:bodyPr wrap="square" lIns="27432" rIns="27432" tIns="27432" bIns="27432" anchor="t">
+          <a:bodyPr wrap="square" lIns="27432" tIns="27432" rIns="27432" bIns="27432" anchor="t">
             <a:spAutoFit/>
           </a:bodyPr>
           <a:lstStyle/>
@@ -7022,6 +7266,7 @@
           <a:lstStyle/>
           <a:p>
             <a:pPr algn="ctr"/>
+            <a:endParaRPr/>
           </a:p>
         </p:txBody>
       </p:sp>
@@ -7067,6 +7312,7 @@
           <a:lstStyle/>
           <a:p>
             <a:pPr algn="ctr"/>
+            <a:endParaRPr/>
           </a:p>
         </p:txBody>
       </p:sp>
@@ -7087,7 +7333,7 @@
           <a:noFill/>
         </p:spPr>
         <p:txBody>
-          <a:bodyPr wrap="square" lIns="27432" rIns="27432" tIns="27432" bIns="27432" anchor="t">
+          <a:bodyPr wrap="square" lIns="27432" tIns="27432" rIns="27432" bIns="27432" anchor="t">
             <a:spAutoFit/>
           </a:bodyPr>
           <a:lstStyle/>
@@ -7126,7 +7372,7 @@
           <a:noFill/>
         </p:spPr>
         <p:txBody>
-          <a:bodyPr wrap="square" lIns="27432" rIns="27432" tIns="27432" bIns="27432" anchor="t">
+          <a:bodyPr wrap="square" lIns="27432" tIns="27432" rIns="27432" bIns="27432" anchor="t">
             <a:spAutoFit/>
           </a:bodyPr>
           <a:lstStyle/>
@@ -7165,7 +7411,7 @@
           <a:noFill/>
         </p:spPr>
         <p:txBody>
-          <a:bodyPr wrap="square" lIns="27432" rIns="27432" tIns="27432" bIns="27432" anchor="t">
+          <a:bodyPr wrap="square" lIns="27432" tIns="27432" rIns="27432" bIns="27432" anchor="t">
             <a:spAutoFit/>
           </a:bodyPr>
           <a:lstStyle/>
@@ -7231,6 +7477,7 @@
           <a:lstStyle/>
           <a:p>
             <a:pPr algn="ctr"/>
+            <a:endParaRPr/>
           </a:p>
         </p:txBody>
       </p:sp>
@@ -7251,7 +7498,7 @@
           <a:noFill/>
         </p:spPr>
         <p:txBody>
-          <a:bodyPr wrap="square" lIns="27432" rIns="27432" tIns="27432" bIns="27432" anchor="t">
+          <a:bodyPr wrap="square" lIns="27432" tIns="27432" rIns="27432" bIns="27432" anchor="t">
             <a:spAutoFit/>
           </a:bodyPr>
           <a:lstStyle/>
@@ -7317,6 +7564,7 @@
           <a:lstStyle/>
           <a:p>
             <a:pPr algn="ctr"/>
+            <a:endParaRPr/>
           </a:p>
         </p:txBody>
       </p:sp>
@@ -7337,7 +7585,7 @@
           <a:noFill/>
         </p:spPr>
         <p:txBody>
-          <a:bodyPr wrap="square" lIns="27432" rIns="27432" tIns="27432" bIns="27432" anchor="t">
+          <a:bodyPr wrap="square" lIns="27432" tIns="27432" rIns="27432" bIns="27432" anchor="t">
             <a:spAutoFit/>
           </a:bodyPr>
           <a:lstStyle/>
@@ -7403,6 +7651,7 @@
           <a:lstStyle/>
           <a:p>
             <a:pPr algn="ctr"/>
+            <a:endParaRPr/>
           </a:p>
         </p:txBody>
       </p:sp>
@@ -7423,7 +7672,7 @@
           <a:noFill/>
         </p:spPr>
         <p:txBody>
-          <a:bodyPr wrap="square" lIns="27432" rIns="27432" tIns="27432" bIns="27432" anchor="t">
+          <a:bodyPr wrap="square" lIns="27432" tIns="27432" rIns="27432" bIns="27432" anchor="t">
             <a:spAutoFit/>
           </a:bodyPr>
           <a:lstStyle/>
@@ -7489,6 +7738,7 @@
           <a:lstStyle/>
           <a:p>
             <a:pPr algn="ctr"/>
+            <a:endParaRPr/>
           </a:p>
         </p:txBody>
       </p:sp>
@@ -7509,7 +7759,7 @@
           <a:noFill/>
         </p:spPr>
         <p:txBody>
-          <a:bodyPr wrap="square" lIns="27432" rIns="27432" tIns="27432" bIns="27432" anchor="t">
+          <a:bodyPr wrap="square" lIns="27432" tIns="27432" rIns="27432" bIns="27432" anchor="t">
             <a:spAutoFit/>
           </a:bodyPr>
           <a:lstStyle/>
@@ -7575,6 +7825,7 @@
           <a:lstStyle/>
           <a:p>
             <a:pPr algn="ctr"/>
+            <a:endParaRPr/>
           </a:p>
         </p:txBody>
       </p:sp>
@@ -7595,7 +7846,7 @@
           <a:noFill/>
         </p:spPr>
         <p:txBody>
-          <a:bodyPr wrap="square" lIns="27432" rIns="27432" tIns="27432" bIns="27432" anchor="t">
+          <a:bodyPr wrap="square" lIns="27432" tIns="27432" rIns="27432" bIns="27432" anchor="t">
             <a:spAutoFit/>
           </a:bodyPr>
           <a:lstStyle/>
@@ -7661,6 +7912,7 @@
           <a:lstStyle/>
           <a:p>
             <a:pPr algn="ctr"/>
+            <a:endParaRPr/>
           </a:p>
         </p:txBody>
       </p:sp>
@@ -7681,7 +7933,7 @@
           <a:noFill/>
         </p:spPr>
         <p:txBody>
-          <a:bodyPr wrap="square" lIns="27432" rIns="27432" tIns="27432" bIns="27432" anchor="t">
+          <a:bodyPr wrap="square" lIns="27432" tIns="27432" rIns="27432" bIns="27432" anchor="t">
             <a:spAutoFit/>
           </a:bodyPr>
           <a:lstStyle/>
@@ -7747,6 +7999,7 @@
           <a:lstStyle/>
           <a:p>
             <a:pPr algn="ctr"/>
+            <a:endParaRPr/>
           </a:p>
         </p:txBody>
       </p:sp>
@@ -7767,7 +8020,7 @@
           <a:noFill/>
         </p:spPr>
         <p:txBody>
-          <a:bodyPr wrap="square" lIns="27432" rIns="27432" tIns="27432" bIns="27432" anchor="t">
+          <a:bodyPr wrap="square" lIns="27432" tIns="27432" rIns="27432" bIns="27432" anchor="t">
             <a:spAutoFit/>
           </a:bodyPr>
           <a:lstStyle/>
@@ -7833,6 +8086,7 @@
           <a:lstStyle/>
           <a:p>
             <a:pPr algn="ctr"/>
+            <a:endParaRPr/>
           </a:p>
         </p:txBody>
       </p:sp>
@@ -7853,7 +8107,7 @@
           <a:noFill/>
         </p:spPr>
         <p:txBody>
-          <a:bodyPr wrap="square" lIns="27432" rIns="27432" tIns="27432" bIns="27432" anchor="t">
+          <a:bodyPr wrap="square" lIns="27432" tIns="27432" rIns="27432" bIns="27432" anchor="t">
             <a:spAutoFit/>
           </a:bodyPr>
           <a:lstStyle/>
@@ -7919,6 +8173,7 @@
           <a:lstStyle/>
           <a:p>
             <a:pPr algn="ctr"/>
+            <a:endParaRPr/>
           </a:p>
         </p:txBody>
       </p:sp>
@@ -7939,7 +8194,7 @@
           <a:noFill/>
         </p:spPr>
         <p:txBody>
-          <a:bodyPr wrap="square" lIns="27432" rIns="27432" tIns="27432" bIns="27432" anchor="t">
+          <a:bodyPr wrap="square" lIns="27432" tIns="27432" rIns="27432" bIns="27432" anchor="t">
             <a:spAutoFit/>
           </a:bodyPr>
           <a:lstStyle/>
@@ -8223,7 +8478,7 @@
           <a:noFill/>
         </p:spPr>
         <p:txBody>
-          <a:bodyPr wrap="square" lIns="27432" rIns="27432" tIns="27432" bIns="27432" anchor="t">
+          <a:bodyPr wrap="square" lIns="27432" tIns="27432" rIns="27432" bIns="27432" anchor="t">
             <a:spAutoFit/>
           </a:bodyPr>
           <a:lstStyle/>
@@ -8254,7 +8509,7 @@
 </file>
 
 <file path=ppt/slides/slide6.xml><?xml version="1.0" encoding="utf-8"?>
-<p:sld xmlns:a="http://schemas.openxmlformats.org/drawingml/2006/main" xmlns:p="http://schemas.openxmlformats.org/presentationml/2006/main" xmlns:r="http://schemas.openxmlformats.org/officeDocument/2006/relationships">
+<p:sld xmlns:a="http://schemas.openxmlformats.org/drawingml/2006/main" xmlns:r="http://schemas.openxmlformats.org/officeDocument/2006/relationships" xmlns:p="http://schemas.openxmlformats.org/presentationml/2006/main">
   <p:cSld>
     <p:bg>
       <p:bgPr>
@@ -8270,7 +8525,14 @@
         <p:cNvGrpSpPr/>
         <p:nvPr/>
       </p:nvGrpSpPr>
-      <p:grpSpPr/>
+      <p:grpSpPr>
+        <a:xfrm>
+          <a:off x="0" y="0"/>
+          <a:ext cx="0" cy="0"/>
+          <a:chOff x="0" y="0"/>
+          <a:chExt cx="0" cy="0"/>
+        </a:xfrm>
+      </p:grpSpPr>
       <p:sp>
         <p:nvSpPr>
           <p:cNvPr id="2" name="Rectangle 1"/>
@@ -8313,6 +8575,7 @@
           <a:lstStyle/>
           <a:p>
             <a:pPr algn="ctr"/>
+            <a:endParaRPr/>
           </a:p>
         </p:txBody>
       </p:sp>
@@ -8333,7 +8596,7 @@
           <a:noFill/>
         </p:spPr>
         <p:txBody>
-          <a:bodyPr wrap="square" lIns="27432" rIns="27432" tIns="27432" bIns="27432" anchor="t">
+          <a:bodyPr wrap="square" lIns="27432" tIns="27432" rIns="27432" bIns="27432" anchor="t">
             <a:spAutoFit/>
           </a:bodyPr>
           <a:lstStyle/>
@@ -8372,7 +8635,7 @@
           <a:noFill/>
         </p:spPr>
         <p:txBody>
-          <a:bodyPr wrap="square" lIns="27432" rIns="27432" tIns="27432" bIns="27432" anchor="t">
+          <a:bodyPr wrap="square" lIns="27432" tIns="27432" rIns="27432" bIns="27432" anchor="t">
             <a:spAutoFit/>
           </a:bodyPr>
           <a:lstStyle/>
@@ -8411,7 +8674,7 @@
           <a:noFill/>
         </p:spPr>
         <p:txBody>
-          <a:bodyPr wrap="square" lIns="27432" rIns="27432" tIns="27432" bIns="27432" anchor="t">
+          <a:bodyPr wrap="square" lIns="27432" tIns="27432" rIns="27432" bIns="27432" anchor="t">
             <a:spAutoFit/>
           </a:bodyPr>
           <a:lstStyle/>
@@ -8475,6 +8738,7 @@
           <a:lstStyle/>
           <a:p>
             <a:pPr algn="ctr"/>
+            <a:endParaRPr/>
           </a:p>
         </p:txBody>
       </p:sp>
@@ -8520,6 +8784,7 @@
           <a:lstStyle/>
           <a:p>
             <a:pPr algn="ctr"/>
+            <a:endParaRPr/>
           </a:p>
         </p:txBody>
       </p:sp>
@@ -8540,7 +8805,7 @@
           <a:noFill/>
         </p:spPr>
         <p:txBody>
-          <a:bodyPr wrap="square" lIns="27432" rIns="27432" tIns="27432" bIns="27432" anchor="t">
+          <a:bodyPr wrap="square" lIns="27432" tIns="27432" rIns="27432" bIns="27432" anchor="t">
             <a:spAutoFit/>
           </a:bodyPr>
           <a:lstStyle/>
@@ -8579,7 +8844,7 @@
           <a:noFill/>
         </p:spPr>
         <p:txBody>
-          <a:bodyPr wrap="square" lIns="27432" rIns="27432" tIns="27432" bIns="27432" anchor="t">
+          <a:bodyPr wrap="square" lIns="27432" tIns="27432" rIns="27432" bIns="27432" anchor="t">
             <a:spAutoFit/>
           </a:bodyPr>
           <a:lstStyle/>
@@ -8645,6 +8910,7 @@
           <a:lstStyle/>
           <a:p>
             <a:pPr algn="ctr"/>
+            <a:endParaRPr/>
           </a:p>
         </p:txBody>
       </p:sp>
@@ -8665,7 +8931,7 @@
           <a:noFill/>
         </p:spPr>
         <p:txBody>
-          <a:bodyPr wrap="square" lIns="27432" rIns="27432" tIns="27432" bIns="27432" anchor="t">
+          <a:bodyPr wrap="square" lIns="27432" tIns="27432" rIns="27432" bIns="27432" anchor="t">
             <a:spAutoFit/>
           </a:bodyPr>
           <a:lstStyle/>
@@ -8731,6 +8997,7 @@
           <a:lstStyle/>
           <a:p>
             <a:pPr algn="ctr"/>
+            <a:endParaRPr/>
           </a:p>
         </p:txBody>
       </p:sp>
@@ -8751,7 +9018,7 @@
           <a:noFill/>
         </p:spPr>
         <p:txBody>
-          <a:bodyPr wrap="square" lIns="27432" rIns="27432" tIns="27432" bIns="27432" anchor="t">
+          <a:bodyPr wrap="square" lIns="27432" tIns="27432" rIns="27432" bIns="27432" anchor="t">
             <a:spAutoFit/>
           </a:bodyPr>
           <a:lstStyle/>
@@ -8817,6 +9084,7 @@
           <a:lstStyle/>
           <a:p>
             <a:pPr algn="ctr"/>
+            <a:endParaRPr/>
           </a:p>
         </p:txBody>
       </p:sp>
@@ -8837,7 +9105,7 @@
           <a:noFill/>
         </p:spPr>
         <p:txBody>
-          <a:bodyPr wrap="square" lIns="27432" rIns="27432" tIns="27432" bIns="27432" anchor="t">
+          <a:bodyPr wrap="square" lIns="27432" tIns="27432" rIns="27432" bIns="27432" anchor="t">
             <a:spAutoFit/>
           </a:bodyPr>
           <a:lstStyle/>
@@ -8903,6 +9171,7 @@
           <a:lstStyle/>
           <a:p>
             <a:pPr algn="ctr"/>
+            <a:endParaRPr/>
           </a:p>
         </p:txBody>
       </p:sp>
@@ -8923,7 +9192,7 @@
           <a:noFill/>
         </p:spPr>
         <p:txBody>
-          <a:bodyPr wrap="square" lIns="27432" rIns="27432" tIns="27432" bIns="27432" anchor="t">
+          <a:bodyPr wrap="square" lIns="27432" tIns="27432" rIns="27432" bIns="27432" anchor="t">
             <a:spAutoFit/>
           </a:bodyPr>
           <a:lstStyle/>
@@ -8989,6 +9258,7 @@
           <a:lstStyle/>
           <a:p>
             <a:pPr algn="ctr"/>
+            <a:endParaRPr/>
           </a:p>
         </p:txBody>
       </p:sp>
@@ -9009,7 +9279,7 @@
           <a:noFill/>
         </p:spPr>
         <p:txBody>
-          <a:bodyPr wrap="square" lIns="27432" rIns="27432" tIns="27432" bIns="27432" anchor="t">
+          <a:bodyPr wrap="square" lIns="27432" tIns="27432" rIns="27432" bIns="27432" anchor="t">
             <a:spAutoFit/>
           </a:bodyPr>
           <a:lstStyle/>
@@ -9040,7 +9310,7 @@
 </file>
 
 <file path=ppt/slides/slide7.xml><?xml version="1.0" encoding="utf-8"?>
-<p:sld xmlns:a="http://schemas.openxmlformats.org/drawingml/2006/main" xmlns:p="http://schemas.openxmlformats.org/presentationml/2006/main" xmlns:r="http://schemas.openxmlformats.org/officeDocument/2006/relationships">
+<p:sld xmlns:a="http://schemas.openxmlformats.org/drawingml/2006/main" xmlns:r="http://schemas.openxmlformats.org/officeDocument/2006/relationships" xmlns:p="http://schemas.openxmlformats.org/presentationml/2006/main">
   <p:cSld>
     <p:bg>
       <p:bgPr>
@@ -9056,7 +9326,14 @@
         <p:cNvGrpSpPr/>
         <p:nvPr/>
       </p:nvGrpSpPr>
-      <p:grpSpPr/>
+      <p:grpSpPr>
+        <a:xfrm>
+          <a:off x="0" y="0"/>
+          <a:ext cx="0" cy="0"/>
+          <a:chOff x="0" y="0"/>
+          <a:chExt cx="0" cy="0"/>
+        </a:xfrm>
+      </p:grpSpPr>
       <p:sp>
         <p:nvSpPr>
           <p:cNvPr id="2" name="Rectangle 1"/>
@@ -9099,6 +9376,7 @@
           <a:lstStyle/>
           <a:p>
             <a:pPr algn="ctr"/>
+            <a:endParaRPr/>
           </a:p>
         </p:txBody>
       </p:sp>
@@ -9119,7 +9397,7 @@
           <a:noFill/>
         </p:spPr>
         <p:txBody>
-          <a:bodyPr wrap="square" lIns="27432" rIns="27432" tIns="27432" bIns="27432" anchor="t">
+          <a:bodyPr wrap="square" lIns="27432" tIns="27432" rIns="27432" bIns="27432" anchor="t">
             <a:spAutoFit/>
           </a:bodyPr>
           <a:lstStyle/>
@@ -9158,7 +9436,7 @@
           <a:noFill/>
         </p:spPr>
         <p:txBody>
-          <a:bodyPr wrap="square" lIns="27432" rIns="27432" tIns="27432" bIns="27432" anchor="t">
+          <a:bodyPr wrap="square" lIns="27432" tIns="27432" rIns="27432" bIns="27432" anchor="t">
             <a:spAutoFit/>
           </a:bodyPr>
           <a:lstStyle/>
@@ -9197,7 +9475,7 @@
           <a:noFill/>
         </p:spPr>
         <p:txBody>
-          <a:bodyPr wrap="square" lIns="27432" rIns="27432" tIns="27432" bIns="27432" anchor="t">
+          <a:bodyPr wrap="square" lIns="27432" tIns="27432" rIns="27432" bIns="27432" anchor="t">
             <a:spAutoFit/>
           </a:bodyPr>
           <a:lstStyle/>
@@ -9261,6 +9539,7 @@
           <a:lstStyle/>
           <a:p>
             <a:pPr algn="ctr"/>
+            <a:endParaRPr/>
           </a:p>
         </p:txBody>
       </p:sp>
@@ -9306,6 +9585,7 @@
           <a:lstStyle/>
           <a:p>
             <a:pPr algn="ctr"/>
+            <a:endParaRPr/>
           </a:p>
         </p:txBody>
       </p:sp>
@@ -9326,7 +9606,7 @@
           <a:noFill/>
         </p:spPr>
         <p:txBody>
-          <a:bodyPr wrap="square" lIns="27432" rIns="27432" tIns="27432" bIns="27432" anchor="t">
+          <a:bodyPr wrap="square" lIns="27432" tIns="27432" rIns="27432" bIns="27432" anchor="t">
             <a:spAutoFit/>
           </a:bodyPr>
           <a:lstStyle/>
@@ -9365,7 +9645,7 @@
           <a:noFill/>
         </p:spPr>
         <p:txBody>
-          <a:bodyPr wrap="square" lIns="27432" rIns="27432" tIns="27432" bIns="27432" anchor="t">
+          <a:bodyPr wrap="square" lIns="27432" tIns="27432" rIns="27432" bIns="27432" anchor="t">
             <a:spAutoFit/>
           </a:bodyPr>
           <a:lstStyle/>
@@ -9431,6 +9711,7 @@
           <a:lstStyle/>
           <a:p>
             <a:pPr algn="ctr"/>
+            <a:endParaRPr/>
           </a:p>
         </p:txBody>
       </p:sp>
@@ -9451,7 +9732,7 @@
           <a:noFill/>
         </p:spPr>
         <p:txBody>
-          <a:bodyPr wrap="square" lIns="27432" rIns="27432" tIns="27432" bIns="27432" anchor="t">
+          <a:bodyPr wrap="square" lIns="27432" tIns="27432" rIns="27432" bIns="27432" anchor="t">
             <a:spAutoFit/>
           </a:bodyPr>
           <a:lstStyle/>
@@ -9490,7 +9771,7 @@
           <a:noFill/>
         </p:spPr>
         <p:txBody>
-          <a:bodyPr wrap="square" lIns="27432" rIns="27432" tIns="27432" bIns="27432" anchor="t">
+          <a:bodyPr wrap="square" lIns="27432" tIns="27432" rIns="27432" bIns="27432" anchor="t">
             <a:spAutoFit/>
           </a:bodyPr>
           <a:lstStyle/>
@@ -9556,6 +9837,7 @@
           <a:lstStyle/>
           <a:p>
             <a:pPr algn="ctr"/>
+            <a:endParaRPr/>
           </a:p>
         </p:txBody>
       </p:sp>
@@ -9576,7 +9858,7 @@
           <a:noFill/>
         </p:spPr>
         <p:txBody>
-          <a:bodyPr wrap="square" lIns="27432" rIns="27432" tIns="27432" bIns="27432" anchor="t">
+          <a:bodyPr wrap="square" lIns="27432" tIns="27432" rIns="27432" bIns="27432" anchor="t">
             <a:spAutoFit/>
           </a:bodyPr>
           <a:lstStyle/>
@@ -9615,7 +9897,7 @@
           <a:noFill/>
         </p:spPr>
         <p:txBody>
-          <a:bodyPr wrap="square" lIns="27432" rIns="27432" tIns="27432" bIns="27432" anchor="t">
+          <a:bodyPr wrap="square" lIns="27432" tIns="27432" rIns="27432" bIns="27432" anchor="t">
             <a:spAutoFit/>
           </a:bodyPr>
           <a:lstStyle/>
@@ -9654,7 +9936,7 @@
           <a:noFill/>
         </p:spPr>
         <p:txBody>
-          <a:bodyPr wrap="square" lIns="27432" rIns="27432" tIns="27432" bIns="27432" anchor="t">
+          <a:bodyPr wrap="square" lIns="27432" tIns="27432" rIns="27432" bIns="27432" anchor="t">
             <a:spAutoFit/>
           </a:bodyPr>
           <a:lstStyle/>
@@ -9693,7 +9975,7 @@
           <a:noFill/>
         </p:spPr>
         <p:txBody>
-          <a:bodyPr wrap="square" lIns="27432" rIns="27432" tIns="27432" bIns="27432" anchor="t">
+          <a:bodyPr wrap="square" lIns="27432" tIns="27432" rIns="27432" bIns="27432" anchor="t">
             <a:spAutoFit/>
           </a:bodyPr>
           <a:lstStyle/>
@@ -9724,7 +10006,7 @@
 </file>
 
 <file path=ppt/slides/slide8.xml><?xml version="1.0" encoding="utf-8"?>
-<p:sld xmlns:a="http://schemas.openxmlformats.org/drawingml/2006/main" xmlns:p="http://schemas.openxmlformats.org/presentationml/2006/main" xmlns:r="http://schemas.openxmlformats.org/officeDocument/2006/relationships">
+<p:sld xmlns:a="http://schemas.openxmlformats.org/drawingml/2006/main" xmlns:r="http://schemas.openxmlformats.org/officeDocument/2006/relationships" xmlns:p="http://schemas.openxmlformats.org/presentationml/2006/main">
   <p:cSld>
     <p:bg>
       <p:bgPr>
@@ -9740,7 +10022,14 @@
         <p:cNvGrpSpPr/>
         <p:nvPr/>
       </p:nvGrpSpPr>
-      <p:grpSpPr/>
+      <p:grpSpPr>
+        <a:xfrm>
+          <a:off x="0" y="0"/>
+          <a:ext cx="0" cy="0"/>
+          <a:chOff x="0" y="0"/>
+          <a:chExt cx="0" cy="0"/>
+        </a:xfrm>
+      </p:grpSpPr>
       <p:sp>
         <p:nvSpPr>
           <p:cNvPr id="2" name="Rectangle 1"/>
@@ -9783,6 +10072,7 @@
           <a:lstStyle/>
           <a:p>
             <a:pPr algn="ctr"/>
+            <a:endParaRPr/>
           </a:p>
         </p:txBody>
       </p:sp>
@@ -9803,7 +10093,7 @@
           <a:noFill/>
         </p:spPr>
         <p:txBody>
-          <a:bodyPr wrap="square" lIns="27432" rIns="27432" tIns="27432" bIns="27432" anchor="t">
+          <a:bodyPr wrap="square" lIns="27432" tIns="27432" rIns="27432" bIns="27432" anchor="t">
             <a:spAutoFit/>
           </a:bodyPr>
           <a:lstStyle/>
@@ -9842,7 +10132,7 @@
           <a:noFill/>
         </p:spPr>
         <p:txBody>
-          <a:bodyPr wrap="square" lIns="27432" rIns="27432" tIns="27432" bIns="27432" anchor="t">
+          <a:bodyPr wrap="square" lIns="27432" tIns="27432" rIns="27432" bIns="27432" anchor="t">
             <a:spAutoFit/>
           </a:bodyPr>
           <a:lstStyle/>
@@ -9881,7 +10171,7 @@
           <a:noFill/>
         </p:spPr>
         <p:txBody>
-          <a:bodyPr wrap="square" lIns="27432" rIns="27432" tIns="27432" bIns="27432" anchor="t">
+          <a:bodyPr wrap="square" lIns="27432" tIns="27432" rIns="27432" bIns="27432" anchor="t">
             <a:spAutoFit/>
           </a:bodyPr>
           <a:lstStyle/>
@@ -9945,6 +10235,7 @@
           <a:lstStyle/>
           <a:p>
             <a:pPr algn="ctr"/>
+            <a:endParaRPr/>
           </a:p>
         </p:txBody>
       </p:sp>
@@ -9990,6 +10281,7 @@
           <a:lstStyle/>
           <a:p>
             <a:pPr algn="ctr"/>
+            <a:endParaRPr/>
           </a:p>
         </p:txBody>
       </p:sp>
@@ -10010,7 +10302,7 @@
           <a:noFill/>
         </p:spPr>
         <p:txBody>
-          <a:bodyPr wrap="square" lIns="27432" rIns="27432" tIns="27432" bIns="27432" anchor="t">
+          <a:bodyPr wrap="square" lIns="27432" tIns="27432" rIns="27432" bIns="27432" anchor="t">
             <a:spAutoFit/>
           </a:bodyPr>
           <a:lstStyle/>
@@ -10049,7 +10341,7 @@
           <a:noFill/>
         </p:spPr>
         <p:txBody>
-          <a:bodyPr wrap="square" lIns="27432" rIns="27432" tIns="27432" bIns="27432" anchor="t">
+          <a:bodyPr wrap="square" lIns="27432" tIns="27432" rIns="27432" bIns="27432" anchor="t">
             <a:spAutoFit/>
           </a:bodyPr>
           <a:lstStyle/>
@@ -10115,6 +10407,7 @@
           <a:lstStyle/>
           <a:p>
             <a:pPr algn="ctr"/>
+            <a:endParaRPr/>
           </a:p>
         </p:txBody>
       </p:sp>
@@ -10135,7 +10428,7 @@
           <a:noFill/>
         </p:spPr>
         <p:txBody>
-          <a:bodyPr wrap="square" lIns="27432" rIns="27432" tIns="27432" bIns="27432" anchor="t">
+          <a:bodyPr wrap="square" lIns="27432" tIns="27432" rIns="27432" bIns="27432" anchor="t">
             <a:spAutoFit/>
           </a:bodyPr>
           <a:lstStyle/>
@@ -10174,7 +10467,7 @@
           <a:noFill/>
         </p:spPr>
         <p:txBody>
-          <a:bodyPr wrap="square" lIns="27432" rIns="27432" tIns="27432" bIns="27432" anchor="t">
+          <a:bodyPr wrap="square" lIns="27432" tIns="27432" rIns="27432" bIns="27432" anchor="t">
             <a:spAutoFit/>
           </a:bodyPr>
           <a:lstStyle/>
@@ -10240,6 +10533,7 @@
           <a:lstStyle/>
           <a:p>
             <a:pPr algn="ctr"/>
+            <a:endParaRPr/>
           </a:p>
         </p:txBody>
       </p:sp>
@@ -10260,7 +10554,7 @@
           <a:noFill/>
         </p:spPr>
         <p:txBody>
-          <a:bodyPr wrap="square" lIns="27432" rIns="27432" tIns="27432" bIns="27432" anchor="t">
+          <a:bodyPr wrap="square" lIns="27432" tIns="27432" rIns="27432" bIns="27432" anchor="t">
             <a:spAutoFit/>
           </a:bodyPr>
           <a:lstStyle/>
@@ -10299,7 +10593,7 @@
           <a:noFill/>
         </p:spPr>
         <p:txBody>
-          <a:bodyPr wrap="square" lIns="27432" rIns="27432" tIns="27432" bIns="27432" anchor="t">
+          <a:bodyPr wrap="square" lIns="27432" tIns="27432" rIns="27432" bIns="27432" anchor="t">
             <a:spAutoFit/>
           </a:bodyPr>
           <a:lstStyle/>
@@ -10365,6 +10659,7 @@
           <a:lstStyle/>
           <a:p>
             <a:pPr algn="ctr"/>
+            <a:endParaRPr/>
           </a:p>
         </p:txBody>
       </p:sp>
@@ -10385,7 +10680,7 @@
           <a:noFill/>
         </p:spPr>
         <p:txBody>
-          <a:bodyPr wrap="square" lIns="27432" rIns="27432" tIns="27432" bIns="27432" anchor="t">
+          <a:bodyPr wrap="square" lIns="27432" tIns="27432" rIns="27432" bIns="27432" anchor="t">
             <a:spAutoFit/>
           </a:bodyPr>
           <a:lstStyle/>
@@ -10424,7 +10719,7 @@
           <a:noFill/>
         </p:spPr>
         <p:txBody>
-          <a:bodyPr wrap="square" lIns="27432" rIns="27432" tIns="27432" bIns="27432" anchor="t">
+          <a:bodyPr wrap="square" lIns="27432" tIns="27432" rIns="27432" bIns="27432" anchor="t">
             <a:spAutoFit/>
           </a:bodyPr>
           <a:lstStyle/>
@@ -10490,6 +10785,7 @@
           <a:lstStyle/>
           <a:p>
             <a:pPr algn="ctr"/>
+            <a:endParaRPr/>
           </a:p>
         </p:txBody>
       </p:sp>
@@ -10510,7 +10806,7 @@
           <a:noFill/>
         </p:spPr>
         <p:txBody>
-          <a:bodyPr wrap="square" lIns="27432" rIns="27432" tIns="27432" bIns="27432" anchor="t">
+          <a:bodyPr wrap="square" lIns="27432" tIns="27432" rIns="27432" bIns="27432" anchor="t">
             <a:spAutoFit/>
           </a:bodyPr>
           <a:lstStyle/>
@@ -10549,7 +10845,7 @@
           <a:noFill/>
         </p:spPr>
         <p:txBody>
-          <a:bodyPr wrap="square" lIns="27432" rIns="27432" tIns="27432" bIns="27432" anchor="t">
+          <a:bodyPr wrap="square" lIns="27432" tIns="27432" rIns="27432" bIns="27432" anchor="t">
             <a:spAutoFit/>
           </a:bodyPr>
           <a:lstStyle/>
@@ -10580,7 +10876,7 @@
 </file>
 
 <file path=ppt/slides/slide9.xml><?xml version="1.0" encoding="utf-8"?>
-<p:sld xmlns:a="http://schemas.openxmlformats.org/drawingml/2006/main" xmlns:p="http://schemas.openxmlformats.org/presentationml/2006/main" xmlns:r="http://schemas.openxmlformats.org/officeDocument/2006/relationships">
+<p:sld xmlns:a="http://schemas.openxmlformats.org/drawingml/2006/main" xmlns:r="http://schemas.openxmlformats.org/officeDocument/2006/relationships" xmlns:p="http://schemas.openxmlformats.org/presentationml/2006/main">
   <p:cSld>
     <p:bg>
       <p:bgPr>
@@ -10596,688 +10892,44 @@
         <p:cNvGrpSpPr/>
         <p:nvPr/>
       </p:nvGrpSpPr>
-      <p:grpSpPr/>
-      <p:sp>
-        <p:nvSpPr>
-          <p:cNvPr id="2" name="Rectangle 1"/>
-          <p:cNvSpPr/>
-          <p:nvPr/>
-        </p:nvSpPr>
-        <p:spPr>
-          <a:xfrm>
-            <a:off x="0" y="0"/>
-            <a:ext cx="12191695" cy="109728"/>
-          </a:xfrm>
-          <a:prstGeom prst="rect">
-            <a:avLst/>
-          </a:prstGeom>
-          <a:solidFill>
-            <a:srgbClr val="24563E"/>
-          </a:solidFill>
-          <a:ln w="10160">
-            <a:solidFill>
-              <a:srgbClr val="24563E"/>
-            </a:solidFill>
-          </a:ln>
-        </p:spPr>
-        <p:style>
-          <a:lnRef idx="1">
-            <a:schemeClr val="accent1"/>
-          </a:lnRef>
-          <a:fillRef idx="3">
-            <a:schemeClr val="accent1"/>
-          </a:fillRef>
-          <a:effectRef idx="2">
-            <a:schemeClr val="accent1"/>
-          </a:effectRef>
-          <a:fontRef idx="minor">
-            <a:schemeClr val="lt1"/>
-          </a:fontRef>
-        </p:style>
-        <p:txBody>
-          <a:bodyPr rtlCol="0" anchor="ctr"/>
-          <a:lstStyle/>
-          <a:p>
-            <a:pPr algn="ctr"/>
-          </a:p>
-        </p:txBody>
-      </p:sp>
-      <p:sp>
-        <p:nvSpPr>
-          <p:cNvPr id="3" name="TextBox 2"/>
-          <p:cNvSpPr txBox="1"/>
-          <p:nvPr/>
-        </p:nvSpPr>
-        <p:spPr>
-          <a:xfrm>
-            <a:off x="658368" y="292608"/>
-            <a:ext cx="5760720" cy="219456"/>
-          </a:xfrm>
-          <a:prstGeom prst="rect">
-            <a:avLst/>
-          </a:prstGeom>
-          <a:noFill/>
-        </p:spPr>
-        <p:txBody>
-          <a:bodyPr wrap="square" lIns="27432" rIns="27432" tIns="27432" bIns="27432" anchor="t">
-            <a:spAutoFit/>
-          </a:bodyPr>
-          <a:lstStyle/>
-          <a:p>
-            <a:pPr algn="l">
-              <a:spcAft>
-                <a:spcPts val="500"/>
-              </a:spcAft>
-              <a:defRPr sz="1000" b="1">
-                <a:solidFill>
-                  <a:srgbClr val="65756C"/>
-                </a:solidFill>
-                <a:latin typeface="Aptos"/>
-              </a:defRPr>
-            </a:pPr>
-            <a:r>
-              <a:t>FREQUENCY  /  PROOFFORGE CYBER</a:t>
-            </a:r>
-          </a:p>
-        </p:txBody>
-      </p:sp>
-      <p:sp>
-        <p:nvSpPr>
-          <p:cNvPr id="4" name="TextBox 3"/>
-          <p:cNvSpPr txBox="1"/>
-          <p:nvPr/>
-        </p:nvSpPr>
-        <p:spPr>
-          <a:xfrm>
-            <a:off x="10698480" y="292608"/>
-            <a:ext cx="822960" cy="219456"/>
-          </a:xfrm>
-          <a:prstGeom prst="rect">
-            <a:avLst/>
-          </a:prstGeom>
-          <a:noFill/>
-        </p:spPr>
-        <p:txBody>
-          <a:bodyPr wrap="square" lIns="27432" rIns="27432" tIns="27432" bIns="27432" anchor="t">
-            <a:spAutoFit/>
-          </a:bodyPr>
-          <a:lstStyle/>
-          <a:p>
-            <a:pPr algn="r">
-              <a:spcAft>
-                <a:spcPts val="500"/>
-              </a:spcAft>
-              <a:defRPr sz="1000" b="1">
-                <a:solidFill>
-                  <a:srgbClr val="65756C"/>
-                </a:solidFill>
-                <a:latin typeface="Aptos"/>
-              </a:defRPr>
-            </a:pPr>
-            <a:r>
-              <a:t>09 / 10</a:t>
-            </a:r>
-          </a:p>
-        </p:txBody>
-      </p:sp>
-      <p:sp>
-        <p:nvSpPr>
-          <p:cNvPr id="5" name="TextBox 4"/>
-          <p:cNvSpPr txBox="1"/>
-          <p:nvPr/>
-        </p:nvSpPr>
-        <p:spPr>
-          <a:xfrm>
-            <a:off x="658368" y="713232"/>
-            <a:ext cx="10881360" cy="502920"/>
-          </a:xfrm>
-          <a:prstGeom prst="rect">
-            <a:avLst/>
-          </a:prstGeom>
-          <a:noFill/>
-        </p:spPr>
-        <p:txBody>
-          <a:bodyPr wrap="square" lIns="27432" rIns="27432" tIns="27432" bIns="27432" anchor="t">
-            <a:spAutoFit/>
-          </a:bodyPr>
-          <a:lstStyle/>
-          <a:p>
-            <a:pPr algn="l">
-              <a:spcAft>
-                <a:spcPts val="500"/>
-              </a:spcAft>
-              <a:defRPr sz="2800" b="1">
-                <a:solidFill>
-                  <a:srgbClr val="192D25"/>
-                </a:solidFill>
-                <a:latin typeface="Aptos"/>
-              </a:defRPr>
-            </a:pPr>
-            <a:r>
-              <a:t>LIMITS &amp; SCALE</a:t>
-            </a:r>
-          </a:p>
-        </p:txBody>
-      </p:sp>
-      <p:sp>
-        <p:nvSpPr>
-          <p:cNvPr id="6" name="Rectangle 5"/>
-          <p:cNvSpPr/>
-          <p:nvPr/>
-        </p:nvSpPr>
-        <p:spPr>
-          <a:xfrm>
-            <a:off x="658368" y="1344168"/>
-            <a:ext cx="10881360" cy="10972"/>
-          </a:xfrm>
-          <a:prstGeom prst="rect">
-            <a:avLst/>
-          </a:prstGeom>
-          <a:solidFill>
-            <a:srgbClr val="DCE4D9"/>
-          </a:solidFill>
-          <a:ln w="10160">
-            <a:solidFill>
-              <a:srgbClr val="DCE4D9"/>
-            </a:solidFill>
-          </a:ln>
-        </p:spPr>
-        <p:style>
-          <a:lnRef idx="1">
-            <a:schemeClr val="accent1"/>
-          </a:lnRef>
-          <a:fillRef idx="3">
-            <a:schemeClr val="accent1"/>
-          </a:fillRef>
-          <a:effectRef idx="2">
-            <a:schemeClr val="accent1"/>
-          </a:effectRef>
-          <a:fontRef idx="minor">
-            <a:schemeClr val="lt1"/>
-          </a:fontRef>
-        </p:style>
-        <p:txBody>
-          <a:bodyPr rtlCol="0" anchor="ctr"/>
-          <a:lstStyle/>
-          <a:p>
-            <a:pPr algn="ctr"/>
-          </a:p>
-        </p:txBody>
-      </p:sp>
-      <p:sp>
-        <p:nvSpPr>
-          <p:cNvPr id="7" name="Rectangle 6"/>
-          <p:cNvSpPr/>
-          <p:nvPr/>
-        </p:nvSpPr>
-        <p:spPr>
-          <a:xfrm>
-            <a:off x="658368" y="6428232"/>
-            <a:ext cx="54864" cy="274320"/>
-          </a:xfrm>
-          <a:prstGeom prst="rect">
-            <a:avLst/>
-          </a:prstGeom>
-          <a:solidFill>
-            <a:srgbClr val="24563E"/>
-          </a:solidFill>
-          <a:ln w="10160">
-            <a:solidFill>
-              <a:srgbClr val="24563E"/>
-            </a:solidFill>
-          </a:ln>
-        </p:spPr>
-        <p:style>
-          <a:lnRef idx="1">
-            <a:schemeClr val="accent1"/>
-          </a:lnRef>
-          <a:fillRef idx="3">
-            <a:schemeClr val="accent1"/>
-          </a:fillRef>
-          <a:effectRef idx="2">
-            <a:schemeClr val="accent1"/>
-          </a:effectRef>
-          <a:fontRef idx="minor">
-            <a:schemeClr val="lt1"/>
-          </a:fontRef>
-        </p:style>
-        <p:txBody>
-          <a:bodyPr rtlCol="0" anchor="ctr"/>
-          <a:lstStyle/>
-          <a:p>
-            <a:pPr algn="ctr"/>
-          </a:p>
-        </p:txBody>
-      </p:sp>
-      <p:sp>
-        <p:nvSpPr>
-          <p:cNvPr id="8" name="TextBox 7"/>
-          <p:cNvSpPr txBox="1"/>
-          <p:nvPr/>
-        </p:nvSpPr>
-        <p:spPr>
-          <a:xfrm>
-            <a:off x="841248" y="6446520"/>
-            <a:ext cx="5943600" cy="164592"/>
-          </a:xfrm>
-          <a:prstGeom prst="rect">
-            <a:avLst/>
-          </a:prstGeom>
-          <a:noFill/>
-        </p:spPr>
-        <p:txBody>
-          <a:bodyPr wrap="square" lIns="27432" rIns="27432" tIns="27432" bIns="27432" anchor="t">
-            <a:spAutoFit/>
-          </a:bodyPr>
-          <a:lstStyle/>
-          <a:p>
-            <a:pPr algn="l">
-              <a:spcAft>
-                <a:spcPts val="500"/>
-              </a:spcAft>
-              <a:defRPr sz="800" b="0">
-                <a:solidFill>
-                  <a:srgbClr val="65756C"/>
-                </a:solidFill>
-                <a:latin typeface="Aptos"/>
-              </a:defRPr>
-            </a:pPr>
-            <a:r>
-              <a:t>TEAM HM26-C3B5  ·  EVIDENCE BEFORE CLAIMS</a:t>
-            </a:r>
-          </a:p>
-        </p:txBody>
-      </p:sp>
-      <p:sp>
-        <p:nvSpPr>
-          <p:cNvPr id="9" name="TextBox 8"/>
-          <p:cNvSpPr txBox="1"/>
-          <p:nvPr/>
-        </p:nvSpPr>
-        <p:spPr>
-          <a:xfrm>
-            <a:off x="10241280" y="6446520"/>
-            <a:ext cx="1280160" cy="164592"/>
-          </a:xfrm>
-          <a:prstGeom prst="rect">
-            <a:avLst/>
-          </a:prstGeom>
-          <a:noFill/>
-        </p:spPr>
-        <p:txBody>
-          <a:bodyPr wrap="square" lIns="27432" rIns="27432" tIns="27432" bIns="27432" anchor="t">
-            <a:spAutoFit/>
-          </a:bodyPr>
-          <a:lstStyle/>
-          <a:p>
-            <a:pPr algn="r">
-              <a:spcAft>
-                <a:spcPts val="500"/>
-              </a:spcAft>
-              <a:defRPr sz="800" b="0">
-                <a:solidFill>
-                  <a:srgbClr val="65756C"/>
-                </a:solidFill>
-                <a:latin typeface="Aptos"/>
-              </a:defRPr>
-            </a:pPr>
-            <a:r>
-              <a:t>FREQUENCY</a:t>
-            </a:r>
-          </a:p>
-        </p:txBody>
-      </p:sp>
-      <p:sp>
-        <p:nvSpPr>
-          <p:cNvPr id="10" name="TextBox 9"/>
-          <p:cNvSpPr txBox="1"/>
-          <p:nvPr/>
-        </p:nvSpPr>
-        <p:spPr>
-          <a:xfrm>
-            <a:off x="713232" y="1691640"/>
-            <a:ext cx="10789920" cy="457200"/>
-          </a:xfrm>
-          <a:prstGeom prst="rect">
-            <a:avLst/>
-          </a:prstGeom>
-          <a:noFill/>
-        </p:spPr>
-        <p:txBody>
-          <a:bodyPr wrap="square" lIns="27432" rIns="27432" tIns="27432" bIns="27432" anchor="t">
-            <a:spAutoFit/>
-          </a:bodyPr>
-          <a:lstStyle/>
-          <a:p>
-            <a:pPr algn="l">
-              <a:spcAft>
-                <a:spcPts val="500"/>
-              </a:spcAft>
-              <a:defRPr sz="2300" b="1">
-                <a:solidFill>
-                  <a:srgbClr val="24563E"/>
-                </a:solidFill>
-                <a:latin typeface="Aptos"/>
-              </a:defRPr>
-            </a:pPr>
-            <a:r>
-              <a:t>50,000 candidates × 4 sections = 200,000 score submissions.</a:t>
-            </a:r>
-          </a:p>
-        </p:txBody>
-      </p:sp>
-      <p:sp>
-        <p:nvSpPr>
-          <p:cNvPr id="11" name="TextBox 10"/>
-          <p:cNvSpPr txBox="1"/>
-          <p:nvPr/>
-        </p:nvSpPr>
-        <p:spPr>
-          <a:xfrm>
-            <a:off x="777240" y="2468880"/>
-            <a:ext cx="228600" cy="329184"/>
-          </a:xfrm>
-          <a:prstGeom prst="rect">
-            <a:avLst/>
-          </a:prstGeom>
-          <a:noFill/>
-        </p:spPr>
-        <p:txBody>
-          <a:bodyPr wrap="square" lIns="27432" rIns="27432" tIns="27432" bIns="27432" anchor="t">
-            <a:spAutoFit/>
-          </a:bodyPr>
-          <a:lstStyle/>
-          <a:p>
-            <a:pPr algn="l">
-              <a:spcAft>
-                <a:spcPts val="500"/>
-              </a:spcAft>
-              <a:defRPr sz="2000" b="1">
-                <a:solidFill>
-                  <a:srgbClr val="24563E"/>
-                </a:solidFill>
-                <a:latin typeface="Aptos"/>
-              </a:defRPr>
-            </a:pPr>
-            <a:r>
-              <a:t>•</a:t>
-            </a:r>
-          </a:p>
-        </p:txBody>
-      </p:sp>
-      <p:sp>
-        <p:nvSpPr>
-          <p:cNvPr id="12" name="TextBox 11"/>
-          <p:cNvSpPr txBox="1"/>
-          <p:nvPr/>
-        </p:nvSpPr>
-        <p:spPr>
-          <a:xfrm>
-            <a:off x="1097280" y="2468880"/>
-            <a:ext cx="10058400" cy="475488"/>
-          </a:xfrm>
-          <a:prstGeom prst="rect">
-            <a:avLst/>
-          </a:prstGeom>
-          <a:noFill/>
-        </p:spPr>
-        <p:txBody>
-          <a:bodyPr wrap="square" lIns="27432" rIns="27432" tIns="27432" bIns="27432" anchor="t">
-            <a:spAutoFit/>
-          </a:bodyPr>
-          <a:lstStyle/>
-          <a:p>
-            <a:pPr algn="l">
-              <a:spcAft>
-                <a:spcPts val="500"/>
-              </a:spcAft>
-              <a:defRPr sz="1700" b="0">
-                <a:solidFill>
-                  <a:srgbClr val="25332C"/>
-                </a:solidFill>
-                <a:latin typeface="Aptos"/>
-              </a:defRPr>
-            </a:pPr>
-            <a:r>
-              <a:t>Over 20 minutes: ~167 requests/second average; deadline bursts are higher.</a:t>
-            </a:r>
-          </a:p>
-        </p:txBody>
-      </p:sp>
-      <p:sp>
-        <p:nvSpPr>
-          <p:cNvPr id="13" name="TextBox 12"/>
-          <p:cNvSpPr txBox="1"/>
-          <p:nvPr/>
-        </p:nvSpPr>
-        <p:spPr>
-          <a:xfrm>
-            <a:off x="777240" y="3182112"/>
-            <a:ext cx="228600" cy="329184"/>
-          </a:xfrm>
-          <a:prstGeom prst="rect">
-            <a:avLst/>
-          </a:prstGeom>
-          <a:noFill/>
-        </p:spPr>
-        <p:txBody>
-          <a:bodyPr wrap="square" lIns="27432" rIns="27432" tIns="27432" bIns="27432" anchor="t">
-            <a:spAutoFit/>
-          </a:bodyPr>
-          <a:lstStyle/>
-          <a:p>
-            <a:pPr algn="l">
-              <a:spcAft>
-                <a:spcPts val="500"/>
-              </a:spcAft>
-              <a:defRPr sz="2000" b="1">
-                <a:solidFill>
-                  <a:srgbClr val="24563E"/>
-                </a:solidFill>
-                <a:latin typeface="Aptos"/>
-              </a:defRPr>
-            </a:pPr>
-            <a:r>
-              <a:t>•</a:t>
-            </a:r>
-          </a:p>
-        </p:txBody>
-      </p:sp>
-      <p:sp>
-        <p:nvSpPr>
-          <p:cNvPr id="14" name="TextBox 13"/>
-          <p:cNvSpPr txBox="1"/>
-          <p:nvPr/>
-        </p:nvSpPr>
-        <p:spPr>
-          <a:xfrm>
-            <a:off x="1097280" y="3182112"/>
-            <a:ext cx="10058400" cy="475488"/>
-          </a:xfrm>
-          <a:prstGeom prst="rect">
-            <a:avLst/>
-          </a:prstGeom>
-          <a:noFill/>
-        </p:spPr>
-        <p:txBody>
-          <a:bodyPr wrap="square" lIns="27432" rIns="27432" tIns="27432" bIns="27432" anchor="t">
-            <a:spAutoFit/>
-          </a:bodyPr>
-          <a:lstStyle/>
-          <a:p>
-            <a:pPr algn="l">
-              <a:spcAft>
-                <a:spcPts val="500"/>
-              </a:spcAft>
-              <a:defRPr sz="1700" b="0">
-                <a:solidFill>
-                  <a:srgbClr val="25332C"/>
-                </a:solidFill>
-                <a:latin typeface="Aptos"/>
-              </a:defRPr>
-            </a:pPr>
-            <a:r>
-              <a:t>First pressure point: synchronous score + separate audit commits; one configured worker; in-memory rate limit.</a:t>
-            </a:r>
-          </a:p>
-        </p:txBody>
-      </p:sp>
-      <p:sp>
-        <p:nvSpPr>
-          <p:cNvPr id="15" name="TextBox 14"/>
-          <p:cNvSpPr txBox="1"/>
-          <p:nvPr/>
-        </p:nvSpPr>
-        <p:spPr>
-          <a:xfrm>
-            <a:off x="777240" y="3895344"/>
-            <a:ext cx="228600" cy="329184"/>
-          </a:xfrm>
-          <a:prstGeom prst="rect">
-            <a:avLst/>
-          </a:prstGeom>
-          <a:noFill/>
-        </p:spPr>
-        <p:txBody>
-          <a:bodyPr wrap="square" lIns="27432" rIns="27432" tIns="27432" bIns="27432" anchor="t">
-            <a:spAutoFit/>
-          </a:bodyPr>
-          <a:lstStyle/>
-          <a:p>
-            <a:pPr algn="l">
-              <a:spcAft>
-                <a:spcPts val="500"/>
-              </a:spcAft>
-              <a:defRPr sz="2000" b="1">
-                <a:solidFill>
-                  <a:srgbClr val="24563E"/>
-                </a:solidFill>
-                <a:latin typeface="Aptos"/>
-              </a:defRPr>
-            </a:pPr>
-            <a:r>
-              <a:t>•</a:t>
-            </a:r>
-          </a:p>
-        </p:txBody>
-      </p:sp>
-      <p:sp>
-        <p:nvSpPr>
-          <p:cNvPr id="16" name="TextBox 15"/>
-          <p:cNvSpPr txBox="1"/>
-          <p:nvPr/>
-        </p:nvSpPr>
-        <p:spPr>
-          <a:xfrm>
-            <a:off x="1097280" y="3895344"/>
-            <a:ext cx="10058400" cy="475488"/>
-          </a:xfrm>
-          <a:prstGeom prst="rect">
-            <a:avLst/>
-          </a:prstGeom>
-          <a:noFill/>
-        </p:spPr>
-        <p:txBody>
-          <a:bodyPr wrap="square" lIns="27432" rIns="27432" tIns="27432" bIns="27432" anchor="t">
-            <a:spAutoFit/>
-          </a:bodyPr>
-          <a:lstStyle/>
-          <a:p>
-            <a:pPr algn="l">
-              <a:spcAft>
-                <a:spcPts val="500"/>
-              </a:spcAft>
-              <a:defRPr sz="1700" b="0">
-                <a:solidFill>
-                  <a:srgbClr val="25332C"/>
-                </a:solidFill>
-                <a:latin typeface="Aptos"/>
-              </a:defRPr>
-            </a:pPr>
-            <a:r>
-              <a:t>First change: durable idempotent submission/outbox queue; shared Redis limits; then load-test.</a:t>
-            </a:r>
-          </a:p>
-        </p:txBody>
-      </p:sp>
-      <p:sp>
-        <p:nvSpPr>
-          <p:cNvPr id="17" name="TextBox 16"/>
-          <p:cNvSpPr txBox="1"/>
-          <p:nvPr/>
-        </p:nvSpPr>
-        <p:spPr>
-          <a:xfrm>
-            <a:off x="777240" y="4608576"/>
-            <a:ext cx="228600" cy="329184"/>
-          </a:xfrm>
-          <a:prstGeom prst="rect">
-            <a:avLst/>
-          </a:prstGeom>
-          <a:noFill/>
-        </p:spPr>
-        <p:txBody>
-          <a:bodyPr wrap="square" lIns="27432" rIns="27432" tIns="27432" bIns="27432" anchor="t">
-            <a:spAutoFit/>
-          </a:bodyPr>
-          <a:lstStyle/>
-          <a:p>
-            <a:pPr algn="l">
-              <a:spcAft>
-                <a:spcPts val="500"/>
-              </a:spcAft>
-              <a:defRPr sz="2000" b="1">
-                <a:solidFill>
-                  <a:srgbClr val="24563E"/>
-                </a:solidFill>
-                <a:latin typeface="Aptos"/>
-              </a:defRPr>
-            </a:pPr>
-            <a:r>
-              <a:t>•</a:t>
-            </a:r>
-          </a:p>
-        </p:txBody>
-      </p:sp>
-      <p:sp>
-        <p:nvSpPr>
-          <p:cNvPr id="18" name="TextBox 17"/>
-          <p:cNvSpPr txBox="1"/>
-          <p:nvPr/>
-        </p:nvSpPr>
-        <p:spPr>
-          <a:xfrm>
-            <a:off x="1097280" y="4608576"/>
-            <a:ext cx="10058400" cy="475488"/>
-          </a:xfrm>
-          <a:prstGeom prst="rect">
-            <a:avLst/>
-          </a:prstGeom>
-          <a:noFill/>
-        </p:spPr>
-        <p:txBody>
-          <a:bodyPr wrap="square" lIns="27432" rIns="27432" tIns="27432" bIns="27432" anchor="t">
-            <a:spAutoFit/>
-          </a:bodyPr>
-          <a:lstStyle/>
-          <a:p>
-            <a:pPr algn="l">
-              <a:spcAft>
-                <a:spcPts val="500"/>
-              </a:spcAft>
-              <a:defRPr sz="1700" b="0">
-                <a:solidFill>
-                  <a:srgbClr val="25332C"/>
-                </a:solidFill>
-                <a:latin typeface="Aptos"/>
-              </a:defRPr>
-            </a:pPr>
-            <a:r>
-              <a:t>Other gaps: synthetic UI data; no isolated labs; no secure file-upload/redaction pipeline.</a:t>
-            </a:r>
-          </a:p>
-        </p:txBody>
-      </p:sp>
+      <p:grpSpPr>
+        <a:xfrm>
+          <a:off x="0" y="0"/>
+          <a:ext cx="0" cy="0"/>
+          <a:chOff x="0" y="0"/>
+          <a:chExt cx="0" cy="0"/>
+        </a:xfrm>
+      </p:grpSpPr>
+      <p:pic>
+        <p:nvPicPr>
+          <p:cNvPr id="20" name="Picture 19">
+            <a:extLst>
+              <a:ext uri="{FF2B5EF4-FFF2-40B4-BE49-F238E27FC236}">
+                <a16:creationId xmlns:a16="http://schemas.microsoft.com/office/drawing/2014/main" id="{2554F5F0-25E3-1F6D-9551-E45278A85B65}"/>
+              </a:ext>
+            </a:extLst>
+          </p:cNvPr>
+          <p:cNvPicPr>
+            <a:picLocks noChangeAspect="1"/>
+          </p:cNvPicPr>
+          <p:nvPr/>
+        </p:nvPicPr>
+        <p:blipFill>
+          <a:blip r:embed="rId2"/>
+          <a:stretch>
+            <a:fillRect/>
+          </a:stretch>
+        </p:blipFill>
+        <p:spPr>
+          <a:xfrm>
+            <a:off x="0" y="163172"/>
+            <a:ext cx="12192000" cy="6531656"/>
+          </a:xfrm>
+          <a:prstGeom prst="rect">
+            <a:avLst/>
+          </a:prstGeom>
+        </p:spPr>
+      </p:pic>
     </p:spTree>
   </p:cSld>
   <p:clrMapOvr>

</xml_diff>